<commit_message>
add: update slide 25 Kyber tree
</commit_message>
<xml_diff>
--- a/presentation/0828_13_Number-Theoretic-Transform.pptx
+++ b/presentation/0828_13_Number-Theoretic-Transform.pptx
@@ -10175,21 +10175,8 @@
             </a:pPr>
             <a:r>
               <a:rPr dirty="0"/>
-              <a:t>NTT의 재귀적 </a:t>
+              <a:t>NTT의 재귀적 계산과 수치</a:t>
             </a:r>
-            <a:r>
-              <a:rPr dirty="0" err="1"/>
-              <a:t>계산과</a:t>
-            </a:r>
-            <a:r>
-              <a:rPr dirty="0"/>
-              <a:t> </a:t>
-            </a:r>
-            <a:r>
-              <a:rPr dirty="0" err="1"/>
-              <a:t>수치</a:t>
-            </a:r>
-            <a:endParaRPr dirty="0"/>
           </a:p>
           <a:p>
             <a:pPr marL="342900" indent="-342900">
@@ -10197,12 +10184,8 @@
               <a:buAutoNum type="arabicPeriod"/>
             </a:pPr>
             <a:r>
-              <a:rPr dirty="0" err="1"/>
-              <a:t>Dilithium</a:t>
-            </a:r>
-            <a:r>
               <a:rPr dirty="0"/>
-              <a:t> NTT</a:t>
+              <a:t>Dilithium NTT</a:t>
             </a:r>
           </a:p>
           <a:p>
@@ -10369,23 +10352,7 @@
               <a:p>
                 <a:r>
                   <a:rPr dirty="0"/>
-                  <a:t>대신 위수 n인 ζ를 쓴다 — 그 결과 NTT 트리에서 마지막 한 단계(선형 인수까지의 완전 분해)가 잘려나가, </a:t>
-                </a:r>
-                <a:r>
-                  <a:rPr dirty="0" err="1"/>
-                  <a:t>리프가</a:t>
-                </a:r>
-                <a:r>
-                  <a:rPr dirty="0"/>
-                  <a:t> </a:t>
-                </a:r>
-                <a:r>
-                  <a:rPr dirty="0" err="1"/>
-                  <a:t>이차식에서</a:t>
-                </a:r>
-                <a:r>
-                  <a:rPr dirty="0"/>
-                  <a:t> 멈춘다</a:t>
+                  <a:t>대신 위수 n인 ζ를 쓴다 — 그 결과 NTT 트리에서 마지막 한 단계(선형 인수까지의 완전 분해)가 잘려나가, 리프가 이차식에서 멈춘다</a:t>
                 </a:r>
               </a:p>
             </p:txBody>
@@ -10556,21 +10523,8 @@
                 </a:r>
                 <a:r>
                   <a:rPr dirty="0"/>
-                  <a:t> </a:t>
+                  <a:t> 위에서 기약이다</a:t>
                 </a:r>
-                <a:r>
-                  <a:rPr dirty="0" err="1"/>
-                  <a:t>위에서</a:t>
-                </a:r>
-                <a:r>
-                  <a:rPr dirty="0"/>
-                  <a:t> </a:t>
-                </a:r>
-                <a:r>
-                  <a:rPr dirty="0" err="1"/>
-                  <a:t>기약이다</a:t>
-                </a:r>
-                <a:endParaRPr dirty="0"/>
               </a:p>
               <a:p>
                 <a:r>
@@ -10809,14 +10763,18 @@
                         <m:t>의 위수가 </m:t>
                       </m:r>
                       <m:r>
-                        <a:rPr lang="en-US" i="0"/>
+                        <a:rPr lang="en-US" i="0">
+                          <a:latin typeface="Cambria Math" panose="02040503050406030204" pitchFamily="18" charset="0"/>
+                        </a:rPr>
                         <m:t>2</m:t>
                       </m:r>
                       <m:r>
                         <m:rPr>
                           <m:sty m:val="p"/>
                         </m:rPr>
-                        <a:rPr lang="en-US" i="0"/>
+                        <a:rPr lang="en-US" i="0">
+                          <a:latin typeface="Cambria Math" panose="02040503050406030204" pitchFamily="18" charset="0"/>
+                        </a:rPr>
                         <m:t>n</m:t>
                       </m:r>
                       <m:r>
@@ -11173,7 +11131,9 @@
                         <m:rPr>
                           <m:sty m:val="p"/>
                         </m:rPr>
-                        <a:rPr lang="en-US" i="0"/>
+                        <a:rPr lang="en-US" i="0">
+                          <a:latin typeface="Cambria Math" panose="02040503050406030204" pitchFamily="18" charset="0"/>
+                        </a:rPr>
                         <m:t>n</m:t>
                       </m:r>
                       <m:r>
@@ -11191,21 +11151,8 @@
               <a:p>
                 <a:r>
                   <a:rPr dirty="0"/>
-                  <a:t>따라서 c의 위수는 정확히 2n인데, 2n은 q−1을 나누지 </a:t>
+                  <a:t>따라서 c의 위수는 정확히 2n인데, 2n은 q−1을 나누지 않으므로 모순</a:t>
                 </a:r>
-                <a:r>
-                  <a:rPr dirty="0" err="1"/>
-                  <a:t>않으므로</a:t>
-                </a:r>
-                <a:r>
-                  <a:rPr dirty="0"/>
-                  <a:t> </a:t>
-                </a:r>
-                <a:r>
-                  <a:rPr dirty="0" err="1"/>
-                  <a:t>모순</a:t>
-                </a:r>
-                <a:endParaRPr dirty="0"/>
               </a:p>
             </p:txBody>
           </p:sp>
@@ -11514,23 +11461,7 @@
               <a:p>
                 <a:r>
                   <a:rPr dirty="0"/>
-                  <a:t>차수 ≤1 </a:t>
-                </a:r>
-                <a:r>
-                  <a:rPr dirty="0" err="1"/>
-                  <a:t>다항식의</a:t>
-                </a:r>
-                <a:r>
-                  <a:rPr dirty="0"/>
-                  <a:t> </a:t>
-                </a:r>
-                <a:r>
-                  <a:rPr dirty="0" err="1"/>
-                  <a:t>이차환</a:t>
-                </a:r>
-                <a:r>
-                  <a:rPr dirty="0"/>
-                  <a:t> — 계수쌍 (c</a:t>
+                  <a:t>차수 ≤1 다항식의 이차환 — 계수쌍 (c</a:t>
                 </a:r>
                 <a:r>
                   <a:rPr baseline="-25000" dirty="0"/>
@@ -12008,15 +11939,7 @@
               <a:p>
                 <a:r>
                   <a:rPr dirty="0"/>
-                  <a:t>NTT는 환 </a:t>
-                </a:r>
-                <a:r>
-                  <a:rPr dirty="0" err="1"/>
-                  <a:t>동형사상이며</a:t>
-                </a:r>
-                <a:r>
-                  <a:rPr dirty="0"/>
-                  <a:t>, 특히 가역이다</a:t>
+                  <a:t>NTT는 환 동형사상이며, 특히 가역이다</a:t>
                 </a:r>
               </a:p>
             </p:txBody>
@@ -14101,7 +14024,7 @@
           <a:p>
             <a:r>
               <a:rPr dirty="0"/>
-              <a:t>Kyber형 NTT 트리 (한 단계 적음)</a:t>
+              <a:t>Kyber형 NTT 트리</a:t>
             </a:r>
           </a:p>
         </p:txBody>
@@ -14118,8 +14041,8 @@
         </p:nvSpPr>
         <p:spPr>
           <a:xfrm>
-            <a:off x="838200" y="1295322"/>
-            <a:ext cx="6000000" cy="4701089"/>
+            <a:off x="838200" y="3429000"/>
+            <a:ext cx="10515600" cy="2567411"/>
           </a:xfrm>
         </p:spPr>
         <p:txBody>
@@ -14127,20 +14050,8 @@
           <a:lstStyle/>
           <a:p>
             <a:r>
-              <a:rPr dirty="0" err="1"/>
-              <a:t>Dilithium</a:t>
-            </a:r>
-            <a:r>
               <a:rPr dirty="0"/>
-              <a:t> </a:t>
-            </a:r>
-            <a:r>
-              <a:rPr dirty="0" err="1"/>
-              <a:t>트리와</a:t>
-            </a:r>
-            <a:r>
-              <a:rPr dirty="0"/>
-              <a:t> 비교하면 마지막 선형 인수 단계가 없다 — 리프가 이차식 x²−ζⁱ에서 멈춘다</a:t>
+              <a:t>Dilithium 트리와 비교하면 마지막 선형 인수 단계가 없다 — 리프가 이차식 x²−ζⁱ에서 멈춘다</a:t>
             </a:r>
           </a:p>
           <a:p>
@@ -14188,57 +14099,53 @@
           </a:p>
         </p:txBody>
       </p:sp>
-      <p:sp>
-        <p:nvSpPr>
-          <p:cNvPr id="7" name="Rectangle 6"/>
-          <p:cNvSpPr/>
+      <p:pic>
+        <p:nvPicPr>
+          <p:cNvPr id="1026" name="Picture 2" descr="스크린샷">
+            <a:extLst>
+              <a:ext uri="{FF2B5EF4-FFF2-40B4-BE49-F238E27FC236}">
+                <a16:creationId xmlns:a16="http://schemas.microsoft.com/office/drawing/2014/main" id="{7A09162F-4BB3-FF74-A33B-C1949391BFC1}"/>
+              </a:ext>
+            </a:extLst>
+          </p:cNvPr>
+          <p:cNvPicPr>
+            <a:picLocks noChangeAspect="1" noChangeArrowheads="1"/>
+          </p:cNvPicPr>
           <p:nvPr/>
-        </p:nvSpPr>
-        <p:spPr>
+        </p:nvPicPr>
+        <p:blipFill>
+          <a:blip r:embed="rId2">
+            <a:extLst>
+              <a:ext uri="{28A0092B-C50C-407E-A947-70E740481C1C}">
+                <a14:useLocalDpi xmlns:a14="http://schemas.microsoft.com/office/drawing/2010/main" val="0"/>
+              </a:ext>
+            </a:extLst>
+          </a:blip>
+          <a:srcRect/>
+          <a:stretch>
+            <a:fillRect/>
+          </a:stretch>
+        </p:blipFill>
+        <p:spPr bwMode="auto">
           <a:xfrm>
-            <a:off x="7100000" y="2400000"/>
-            <a:ext cx="4253600" cy="3200000"/>
+            <a:off x="3571875" y="1295322"/>
+            <a:ext cx="5048250" cy="1828800"/>
           </a:xfrm>
           <a:prstGeom prst="rect">
             <a:avLst/>
           </a:prstGeom>
           <a:noFill/>
-          <a:ln>
-            <a:solidFill>
-              <a:srgbClr val="A0A0A0"/>
-            </a:solidFill>
-            <a:prstDash val="dash"/>
-          </a:ln>
+          <a:extLst>
+            <a:ext uri="{909E8E84-426E-40DD-AFC4-6F175D3DCCD1}">
+              <a14:hiddenFill xmlns:a14="http://schemas.microsoft.com/office/drawing/2010/main">
+                <a:solidFill>
+                  <a:srgbClr val="FFFFFF"/>
+                </a:solidFill>
+              </a14:hiddenFill>
+            </a:ext>
+          </a:extLst>
         </p:spPr>
-        <p:style>
-          <a:lnRef idx="1">
-            <a:schemeClr val="accent1"/>
-          </a:lnRef>
-          <a:fillRef idx="3">
-            <a:schemeClr val="accent1"/>
-          </a:fillRef>
-          <a:effectRef idx="2">
-            <a:schemeClr val="accent1"/>
-          </a:effectRef>
-          <a:fontRef idx="minor">
-            <a:schemeClr val="lt1"/>
-          </a:fontRef>
-        </p:style>
-        <p:txBody>
-          <a:bodyPr wrap="square" rtlCol="0" anchor="ctr"/>
-          <a:lstStyle/>
-          <a:p>
-            <a:r>
-              <a:rPr dirty="0">
-                <a:solidFill>
-                  <a:srgbClr val="595959"/>
-                </a:solidFill>
-              </a:rPr>
-              <a:t>[그림] V4-slides-Kyber-and-Dilithium.pdf p.162 — Kyber형 NTT 트리 (x⁸+1 → 4개의 이차식 리프)</a:t>
-            </a:r>
-          </a:p>
-        </p:txBody>
-      </p:sp>
+      </p:pic>
     </p:spTree>
   </p:cSld>
   <p:clrMapOvr>
@@ -14620,8 +14527,8 @@
           </a:p>
         </p:txBody>
       </p:sp>
-      <mc:AlternateContent xmlns:mc="http://schemas.openxmlformats.org/markup-compatibility/2006" xmlns:a14="http://schemas.microsoft.com/office/drawing/2010/main">
-        <mc:Choice Requires="a14">
+      <mc:AlternateContent xmlns:mc="http://schemas.openxmlformats.org/markup-compatibility/2006">
+        <mc:Choice xmlns:a14="http://schemas.microsoft.com/office/drawing/2010/main" Requires="a14">
           <p:sp>
             <p:nvSpPr>
               <p:cNvPr id="3" name="Content Placeholder 2"/>
@@ -14644,7 +14551,14 @@
               <a:p>
                 <a:r>
                   <a:rPr dirty="0"/>
-                  <a:t>같은 a, b를 앞서 쓴 Kyber형 파라미터 q=137, ζ=10(위수 8)으로 곱한다 — 성분이 스칼라가 아니라 Q</a:t>
+                  <a:t>같은 a, b를 앞서 쓴 Kyber형 파라미터 q=137, ζ=10(위수 8)으로 곱한다 </a:t>
+                </a:r>
+                <a:br>
+                  <a:rPr lang="en-US" dirty="0"/>
+                </a:br>
+                <a:r>
+                  <a:rPr dirty="0"/>
+                  <a:t>— 성분이 스칼라가 아니라 Q</a:t>
                 </a:r>
                 <a:r>
                   <a:rPr baseline="-25000" dirty="0"/>
@@ -14874,7 +14788,7 @@
             </p:txBody>
           </p:sp>
         </mc:Choice>
-        <mc:Fallback xmlns="">
+        <mc:Fallback>
           <p:sp>
             <p:nvSpPr>
               <p:cNvPr id="3" name="Content Placeholder 2"/>
@@ -16106,8 +16020,8 @@
           </a:p>
         </p:txBody>
       </p:sp>
-      <mc:AlternateContent xmlns:mc="http://schemas.openxmlformats.org/markup-compatibility/2006" xmlns:a14="http://schemas.microsoft.com/office/drawing/2010/main">
-        <mc:Choice Requires="a14">
+      <mc:AlternateContent xmlns:mc="http://schemas.openxmlformats.org/markup-compatibility/2006">
+        <mc:Choice xmlns:a14="http://schemas.microsoft.com/office/drawing/2010/main" Requires="a14">
           <p:sp>
             <p:nvSpPr>
               <p:cNvPr id="3" name="Content Placeholder 2"/>
@@ -16506,7 +16420,14 @@
                 </a:r>
                 <a:r>
                   <a:rPr dirty="0"/>
-                  <a:t>은 ζ의 홀수 거듭제곱 128개를 트리 리프 순서로 재배열한 것 — 성분 집합은 </a:t>
+                  <a:t>은 ζ의 홀수 거듭제곱 128개를 트리 리프 순서로 재배열한 것 </a:t>
+                </a:r>
+                <a:br>
+                  <a:rPr lang="en-US" dirty="0"/>
+                </a:br>
+                <a:r>
+                  <a:rPr dirty="0"/>
+                  <a:t>— 성분 집합은 </a:t>
                 </a:r>
                 <a14:m>
                   <m:oMath xmlns:m="http://schemas.openxmlformats.org/officeDocument/2006/math">
@@ -16613,7 +16534,7 @@
             </p:txBody>
           </p:sp>
         </mc:Choice>
-        <mc:Fallback xmlns="">
+        <mc:Fallback>
           <p:sp>
             <p:nvSpPr>
               <p:cNvPr id="3" name="Content Placeholder 2"/>
@@ -17824,8 +17745,8 @@
           </a:p>
         </p:txBody>
       </p:sp>
-      <mc:AlternateContent xmlns:mc="http://schemas.openxmlformats.org/markup-compatibility/2006" xmlns:a14="http://schemas.microsoft.com/office/drawing/2010/main">
-        <mc:Choice Requires="a14">
+      <mc:AlternateContent xmlns:mc="http://schemas.openxmlformats.org/markup-compatibility/2006">
+        <mc:Choice xmlns:a14="http://schemas.microsoft.com/office/drawing/2010/main" Requires="a14">
           <p:sp>
             <p:nvSpPr>
               <p:cNvPr id="3" name="Content Placeholder 2"/>
@@ -18180,13 +18101,13 @@
               <a:p>
                 <a:r>
                   <a:rPr dirty="0"/>
-                  <a:t>NTT를 쓰면 O(n log n), 고전 알고리즘은 O(n²) — 다음 두 슬라이드에서 비교한다</a:t>
+                  <a:t>NTT를 쓰면 O(n log n), 고전 알고리즘은 O(n²)</a:t>
                 </a:r>
               </a:p>
             </p:txBody>
           </p:sp>
         </mc:Choice>
-        <mc:Fallback xmlns="">
+        <mc:Fallback>
           <p:sp>
             <p:nvSpPr>
               <p:cNvPr id="3" name="Content Placeholder 2"/>
@@ -20026,23 +19947,7 @@
           <a:p>
             <a:r>
               <a:rPr dirty="0"/>
-              <a:t>Kyber NTT는 표준 NTT 트리에서 마지막 한 </a:t>
-            </a:r>
-            <a:r>
-              <a:rPr dirty="0" err="1"/>
-              <a:t>층을</a:t>
-            </a:r>
-            <a:r>
-              <a:rPr dirty="0"/>
-              <a:t> </a:t>
-            </a:r>
-            <a:r>
-              <a:rPr dirty="0" err="1"/>
-              <a:t>가지치기한</a:t>
-            </a:r>
-            <a:r>
-              <a:rPr dirty="0"/>
-              <a:t> 것과 같다 — 위수 2n인 ζ가 없어 일차식까지 못 내려간다</a:t>
+              <a:t>Kyber NTT는 표준 NTT 트리에서 마지막 한 층을 가지치기한 것과 같다 — 위수 2n인 ζ가 없어 일차식까지 못 내려간다</a:t>
             </a:r>
           </a:p>
         </p:txBody>
@@ -24377,34 +24282,9 @@
                   </m:oMath>
                 </a14:m>
                 <a:r>
-                  <a:rPr dirty="0" err="1"/>
-                  <a:t>에서</a:t>
+                  <a:rPr dirty="0"/>
+                  <a:t>에서 평가한 것; NTT⁻¹는 다항식 보간</a:t>
                 </a:r>
-                <a:r>
-                  <a:rPr dirty="0"/>
-                  <a:t> </a:t>
-                </a:r>
-                <a:r>
-                  <a:rPr dirty="0" err="1"/>
-                  <a:t>평가한</a:t>
-                </a:r>
-                <a:r>
-                  <a:rPr dirty="0"/>
-                  <a:t> 것; NTT⁻¹는 </a:t>
-                </a:r>
-                <a:r>
-                  <a:rPr dirty="0" err="1"/>
-                  <a:t>다항식</a:t>
-                </a:r>
-                <a:r>
-                  <a:rPr dirty="0"/>
-                  <a:t> </a:t>
-                </a:r>
-                <a:r>
-                  <a:rPr dirty="0" err="1"/>
-                  <a:t>보간</a:t>
-                </a:r>
-                <a:endParaRPr dirty="0"/>
               </a:p>
               <a:p>
                 <a:r>
@@ -25128,23 +25008,7 @@
               <a:p>
                 <a:r>
                   <a:rPr dirty="0"/>
-                  <a:t>NTT(a)의 각 성분은 다항식 </a:t>
-                </a:r>
-                <a:r>
-                  <a:rPr dirty="0" err="1"/>
-                  <a:t>나머지</a:t>
-                </a:r>
-                <a:r>
-                  <a:rPr dirty="0"/>
-                  <a:t> </a:t>
-                </a:r>
-                <a:r>
-                  <a:rPr dirty="0" err="1"/>
-                  <a:t>정리에</a:t>
-                </a:r>
-                <a:r>
-                  <a:rPr dirty="0"/>
-                  <a:t> 의해</a:t>
+                  <a:t>NTT(a)의 각 성분은 다항식 나머지 정리에 의해</a:t>
                 </a:r>
               </a:p>
               <a:p>

</xml_diff>

<commit_message>
add: modify NTT ppt
</commit_message>
<xml_diff>
--- a/presentation/0828_13_Number-Theoretic-Transform.pptx
+++ b/presentation/0828_13_Number-Theoretic-Transform.pptx
@@ -5,44 +5,44 @@
     <p:sldMasterId id="2147483648" r:id="rId1"/>
   </p:sldMasterIdLst>
   <p:notesMasterIdLst>
-    <p:notesMasterId r:id="rId34"/>
+    <p:notesMasterId r:id="rId37"/>
   </p:notesMasterIdLst>
   <p:sldIdLst>
     <p:sldId id="256" r:id="rId2"/>
     <p:sldId id="257" r:id="rId3"/>
-    <p:sldId id="288" r:id="rId40"/>
-    <p:sldId id="289" r:id="rId41"/>
-    <p:sldId id="290" r:id="rId42"/>
-    <p:sldId id="258" r:id="rId4"/>
-    <p:sldId id="259" r:id="rId5"/>
-    <p:sldId id="260" r:id="rId6"/>
-    <p:sldId id="261" r:id="rId7"/>
-    <p:sldId id="262" r:id="rId8"/>
-    <p:sldId id="263" r:id="rId9"/>
-    <p:sldId id="264" r:id="rId10"/>
-    <p:sldId id="265" r:id="rId11"/>
-    <p:sldId id="266" r:id="rId12"/>
-    <p:sldId id="267" r:id="rId13"/>
-    <p:sldId id="268" r:id="rId14"/>
-    <p:sldId id="269" r:id="rId15"/>
-    <p:sldId id="270" r:id="rId16"/>
-    <p:sldId id="271" r:id="rId17"/>
-    <p:sldId id="272" r:id="rId18"/>
-    <p:sldId id="273" r:id="rId19"/>
-    <p:sldId id="274" r:id="rId20"/>
-    <p:sldId id="275" r:id="rId21"/>
-    <p:sldId id="276" r:id="rId22"/>
-    <p:sldId id="277" r:id="rId23"/>
-    <p:sldId id="278" r:id="rId24"/>
-    <p:sldId id="279" r:id="rId25"/>
-    <p:sldId id="280" r:id="rId26"/>
-    <p:sldId id="281" r:id="rId27"/>
-    <p:sldId id="282" r:id="rId28"/>
-    <p:sldId id="283" r:id="rId29"/>
-    <p:sldId id="284" r:id="rId30"/>
-    <p:sldId id="285" r:id="rId31"/>
-    <p:sldId id="286" r:id="rId32"/>
-    <p:sldId id="287" r:id="rId33"/>
+    <p:sldId id="288" r:id="rId4"/>
+    <p:sldId id="289" r:id="rId5"/>
+    <p:sldId id="290" r:id="rId6"/>
+    <p:sldId id="258" r:id="rId7"/>
+    <p:sldId id="259" r:id="rId8"/>
+    <p:sldId id="260" r:id="rId9"/>
+    <p:sldId id="261" r:id="rId10"/>
+    <p:sldId id="262" r:id="rId11"/>
+    <p:sldId id="263" r:id="rId12"/>
+    <p:sldId id="264" r:id="rId13"/>
+    <p:sldId id="265" r:id="rId14"/>
+    <p:sldId id="266" r:id="rId15"/>
+    <p:sldId id="267" r:id="rId16"/>
+    <p:sldId id="268" r:id="rId17"/>
+    <p:sldId id="269" r:id="rId18"/>
+    <p:sldId id="270" r:id="rId19"/>
+    <p:sldId id="271" r:id="rId20"/>
+    <p:sldId id="272" r:id="rId21"/>
+    <p:sldId id="273" r:id="rId22"/>
+    <p:sldId id="274" r:id="rId23"/>
+    <p:sldId id="275" r:id="rId24"/>
+    <p:sldId id="276" r:id="rId25"/>
+    <p:sldId id="277" r:id="rId26"/>
+    <p:sldId id="278" r:id="rId27"/>
+    <p:sldId id="279" r:id="rId28"/>
+    <p:sldId id="280" r:id="rId29"/>
+    <p:sldId id="281" r:id="rId30"/>
+    <p:sldId id="282" r:id="rId31"/>
+    <p:sldId id="283" r:id="rId32"/>
+    <p:sldId id="284" r:id="rId33"/>
+    <p:sldId id="285" r:id="rId34"/>
+    <p:sldId id="286" r:id="rId35"/>
+    <p:sldId id="287" r:id="rId36"/>
   </p:sldIdLst>
   <p:sldSz cx="12192000" cy="6858000"/>
   <p:notesSz cx="6858000" cy="9144000"/>
@@ -589,7 +589,7 @@
           <a:p>
             <a:fld id="{513BC5EA-D886-4875-B891-B25A6CC49088}" type="slidenum">
               <a:rPr lang="ko-KR" altLang="en-US" smtClean="0"/>
-              <a:t>3</a:t>
+              <a:t>6</a:t>
             </a:fld>
             <a:endParaRPr lang="ko-KR" altLang="en-US" dirty="0"/>
           </a:p>
@@ -661,7 +661,7 @@
               <a:t>, DFT </a:t>
             </a:r>
             <a:r>
-              <a:rPr lang="ko-KR" altLang="en-US" dirty="0" err="1"/>
+              <a:rPr lang="ko-KR" altLang="en-US" dirty="0"/>
               <a:t>다룰지말지</a:t>
             </a:r>
             <a:r>
@@ -689,7 +689,7 @@
           <a:p>
             <a:fld id="{513BC5EA-D886-4875-B891-B25A6CC49088}" type="slidenum">
               <a:rPr lang="ko-KR" altLang="en-US" smtClean="0"/>
-              <a:t>4</a:t>
+              <a:t>7</a:t>
             </a:fld>
             <a:endParaRPr lang="ko-KR" altLang="en-US" dirty="0"/>
           </a:p>
@@ -752,10 +752,7 @@
           <a:bodyPr/>
           <a:lstStyle/>
           <a:p>
-            <a:r>
-              <a:rPr lang="ko-KR" altLang="en-US" dirty="0"/>
-              <a:t>동그라미 뭐라고 부를지</a:t>
-            </a:r>
+            <a:endParaRPr lang="ko-KR" altLang="en-US" dirty="0"/>
           </a:p>
         </p:txBody>
       </p:sp>
@@ -776,7 +773,7 @@
           <a:p>
             <a:fld id="{513BC5EA-D886-4875-B891-B25A6CC49088}" type="slidenum">
               <a:rPr lang="ko-KR" altLang="en-US" smtClean="0"/>
-              <a:t>5</a:t>
+              <a:t>8</a:t>
             </a:fld>
             <a:endParaRPr lang="ko-KR" altLang="en-US" dirty="0"/>
           </a:p>
@@ -4977,7 +4974,7 @@
           <a:p>
             <a:fld id="{4438A2D4-3867-488E-A04E-7BFFCAED45A6}" type="slidenum">
               <a:rPr lang="ko-KR" altLang="en-US" smtClean="0"/>
-              <a:t>7</a:t>
+              <a:t>10</a:t>
             </a:fld>
             <a:endParaRPr lang="ko-KR" altLang="en-US" dirty="0"/>
           </a:p>
@@ -5442,7 +5439,7 @@
           <a:p>
             <a:fld id="{4438A2D4-3867-488E-A04E-7BFFCAED45A6}" type="slidenum">
               <a:rPr lang="ko-KR" altLang="en-US" smtClean="0"/>
-              <a:t>8</a:t>
+              <a:t>11</a:t>
             </a:fld>
             <a:endParaRPr lang="ko-KR" altLang="en-US" dirty="0"/>
           </a:p>
@@ -6543,7 +6540,7 @@
           <a:p>
             <a:fld id="{4438A2D4-3867-488E-A04E-7BFFCAED45A6}" type="slidenum">
               <a:rPr lang="ko-KR" altLang="en-US" smtClean="0"/>
-              <a:t>9</a:t>
+              <a:t>12</a:t>
             </a:fld>
             <a:endParaRPr lang="ko-KR" altLang="en-US" dirty="0"/>
           </a:p>
@@ -6671,7 +6668,7 @@
           <a:p>
             <a:fld id="{4438A2D4-3867-488E-A04E-7BFFCAED45A6}" type="slidenum">
               <a:rPr lang="ko-KR" altLang="en-US" smtClean="0"/>
-              <a:t>10</a:t>
+              <a:t>13</a:t>
             </a:fld>
             <a:endParaRPr lang="ko-KR" altLang="en-US" dirty="0"/>
           </a:p>
@@ -7529,7 +7526,7 @@
           <a:p>
             <a:fld id="{4438A2D4-3867-488E-A04E-7BFFCAED45A6}" type="slidenum">
               <a:rPr lang="ko-KR" altLang="en-US" smtClean="0"/>
-              <a:t>11</a:t>
+              <a:t>14</a:t>
             </a:fld>
             <a:endParaRPr lang="ko-KR" altLang="en-US" dirty="0"/>
           </a:p>
@@ -7857,7 +7854,7 @@
           <a:p>
             <a:fld id="{4438A2D4-3867-488E-A04E-7BFFCAED45A6}" type="slidenum">
               <a:rPr lang="ko-KR" altLang="en-US" smtClean="0"/>
-              <a:t>12</a:t>
+              <a:t>15</a:t>
             </a:fld>
             <a:endParaRPr lang="ko-KR" altLang="en-US" dirty="0"/>
           </a:p>
@@ -8567,7 +8564,7 @@
           <a:p>
             <a:fld id="{4438A2D4-3867-488E-A04E-7BFFCAED45A6}" type="slidenum">
               <a:rPr lang="ko-KR" altLang="en-US" smtClean="0"/>
-              <a:t>13</a:t>
+              <a:t>16</a:t>
             </a:fld>
             <a:endParaRPr lang="ko-KR" altLang="en-US" dirty="0"/>
           </a:p>
@@ -8918,7 +8915,7 @@
           <a:p>
             <a:fld id="{4438A2D4-3867-488E-A04E-7BFFCAED45A6}" type="slidenum">
               <a:rPr lang="ko-KR" altLang="en-US" smtClean="0"/>
-              <a:t>14</a:t>
+              <a:t>17</a:t>
             </a:fld>
             <a:endParaRPr lang="ko-KR" altLang="en-US" dirty="0"/>
           </a:p>
@@ -10068,7 +10065,7 @@
           <a:p>
             <a:fld id="{4438A2D4-3867-488E-A04E-7BFFCAED45A6}" type="slidenum">
               <a:rPr lang="ko-KR" altLang="en-US" smtClean="0"/>
-              <a:t>15</a:t>
+              <a:t>18</a:t>
             </a:fld>
             <a:endParaRPr lang="ko-KR" altLang="en-US" dirty="0"/>
           </a:p>
@@ -10769,7 +10766,7 @@
           <a:p>
             <a:fld id="{4438A2D4-3867-488E-A04E-7BFFCAED45A6}" type="slidenum">
               <a:rPr lang="ko-KR" altLang="en-US" smtClean="0"/>
-              <a:t>16</a:t>
+              <a:t>19</a:t>
             </a:fld>
             <a:endParaRPr lang="ko-KR" altLang="en-US" dirty="0"/>
           </a:p>
@@ -11131,7 +11128,7 @@
           <a:p>
             <a:fld id="{4438A2D4-3867-488E-A04E-7BFFCAED45A6}" type="slidenum">
               <a:rPr lang="ko-KR" altLang="en-US" smtClean="0"/>
-              <a:t>17</a:t>
+              <a:t>20</a:t>
             </a:fld>
             <a:endParaRPr lang="ko-KR" altLang="en-US" dirty="0"/>
           </a:p>
@@ -11297,7 +11294,7 @@
           <a:p>
             <a:fld id="{4438A2D4-3867-488E-A04E-7BFFCAED45A6}" type="slidenum">
               <a:rPr lang="ko-KR" altLang="en-US" smtClean="0"/>
-              <a:t>18</a:t>
+              <a:t>21</a:t>
             </a:fld>
             <a:endParaRPr lang="ko-KR" altLang="en-US" dirty="0"/>
           </a:p>
@@ -12038,7 +12035,7 @@
           <a:p>
             <a:fld id="{4438A2D4-3867-488E-A04E-7BFFCAED45A6}" type="slidenum">
               <a:rPr lang="ko-KR" altLang="en-US" smtClean="0"/>
-              <a:t>19</a:t>
+              <a:t>22</a:t>
             </a:fld>
             <a:endParaRPr lang="ko-KR" altLang="en-US" dirty="0"/>
           </a:p>
@@ -13093,7 +13090,7 @@
           <a:p>
             <a:fld id="{4438A2D4-3867-488E-A04E-7BFFCAED45A6}" type="slidenum">
               <a:rPr lang="ko-KR" altLang="en-US" smtClean="0"/>
-              <a:t>20</a:t>
+              <a:t>23</a:t>
             </a:fld>
             <a:endParaRPr lang="ko-KR" altLang="en-US" dirty="0"/>
           </a:p>
@@ -13892,7 +13889,7 @@
           <a:p>
             <a:fld id="{4438A2D4-3867-488E-A04E-7BFFCAED45A6}" type="slidenum">
               <a:rPr lang="ko-KR" altLang="en-US" smtClean="0"/>
-              <a:t>21</a:t>
+              <a:t>24</a:t>
             </a:fld>
             <a:endParaRPr lang="ko-KR" altLang="en-US" dirty="0"/>
           </a:p>
@@ -14680,7 +14677,7 @@
           <a:p>
             <a:fld id="{4438A2D4-3867-488E-A04E-7BFFCAED45A6}" type="slidenum">
               <a:rPr lang="ko-KR" altLang="en-US" smtClean="0"/>
-              <a:t>22</a:t>
+              <a:t>25</a:t>
             </a:fld>
             <a:endParaRPr lang="ko-KR" altLang="en-US" dirty="0"/>
           </a:p>
@@ -15556,7 +15553,7 @@
           <a:p>
             <a:fld id="{4438A2D4-3867-488E-A04E-7BFFCAED45A6}" type="slidenum">
               <a:rPr lang="ko-KR" altLang="en-US" smtClean="0"/>
-              <a:t>23</a:t>
+              <a:t>26</a:t>
             </a:fld>
             <a:endParaRPr lang="ko-KR" altLang="en-US" dirty="0"/>
           </a:p>
@@ -16645,7 +16642,7 @@
           <a:p>
             <a:fld id="{4438A2D4-3867-488E-A04E-7BFFCAED45A6}" type="slidenum">
               <a:rPr lang="ko-KR" altLang="en-US" smtClean="0"/>
-              <a:t>24</a:t>
+              <a:t>27</a:t>
             </a:fld>
             <a:endParaRPr lang="ko-KR" altLang="en-US" dirty="0"/>
           </a:p>
@@ -16767,7 +16764,7 @@
           <a:p>
             <a:fld id="{4438A2D4-3867-488E-A04E-7BFFCAED45A6}" type="slidenum">
               <a:rPr lang="ko-KR" altLang="en-US" smtClean="0"/>
-              <a:t>25</a:t>
+              <a:t>28</a:t>
             </a:fld>
             <a:endParaRPr lang="ko-KR" altLang="en-US" dirty="0"/>
           </a:p>
@@ -17143,7 +17140,7 @@
           <a:p>
             <a:fld id="{4438A2D4-3867-488E-A04E-7BFFCAED45A6}" type="slidenum">
               <a:rPr lang="ko-KR" altLang="en-US" smtClean="0"/>
-              <a:t>26</a:t>
+              <a:t>29</a:t>
             </a:fld>
             <a:endParaRPr lang="ko-KR" altLang="en-US" dirty="0"/>
           </a:p>
@@ -17158,7 +17155,7 @@
 </file>
 
 <file path=ppt/slides/slide3.xml><?xml version="1.0" encoding="utf-8"?>
-<p:sld xmlns:a="http://schemas.openxmlformats.org/drawingml/2006/main" xmlns:p="http://schemas.openxmlformats.org/presentationml/2006/main" xmlns:r="http://schemas.openxmlformats.org/officeDocument/2006/relationships">
+<p:sld xmlns:a="http://schemas.openxmlformats.org/drawingml/2006/main" xmlns:r="http://schemas.openxmlformats.org/officeDocument/2006/relationships" xmlns:p="http://schemas.openxmlformats.org/presentationml/2006/main">
   <p:cSld>
     <p:spTree>
       <p:nvGrpSpPr>
@@ -17166,7 +17163,14 @@
         <p:cNvGrpSpPr/>
         <p:nvPr/>
       </p:nvGrpSpPr>
-      <p:grpSpPr/>
+      <p:grpSpPr>
+        <a:xfrm>
+          <a:off x="0" y="0"/>
+          <a:ext cx="0" cy="0"/>
+          <a:chOff x="0" y="0"/>
+          <a:chExt cx="0" cy="0"/>
+        </a:xfrm>
+      </p:grpSpPr>
       <p:sp>
         <p:nvSpPr>
           <p:cNvPr id="2" name="Title 1"/>
@@ -17188,6 +17192,7 @@
           <a:lstStyle/>
           <a:p>
             <a:r>
+              <a:rPr dirty="0"/>
               <a:t>힌트 비트 1개로 캐리를 전달할 수 있는가</a:t>
             </a:r>
           </a:p>
@@ -17215,25 +17220,44 @@
               <a:bodyPr wrap="square"/>
               <a:lstStyle/>
               <a:p>
-                <a:pPr/>
                 <a:r>
+                  <a:rPr dirty="0"/>
                   <a:t>t를 압축하면 검증자가 계산할 수 있는 것은 </a:t>
                 </a:r>
-                <a14:m xmlns:m="http://schemas.openxmlformats.org/officeDocument/2006/math">
-                  <m:oMath xmlns:mml="http://www.w3.org/1998/Math/MathML">
+                <a14:m>
+                  <m:oMath xmlns:m="http://schemas.openxmlformats.org/officeDocument/2006/math">
                     <m:r>
                       <a:rPr lang="en-US" i="1">
                         <a:latin typeface="Cambria Math"/>
                       </a:rPr>
-                      <m:t>w−c</m:t>
+                      <m:t>𝑤</m:t>
+                    </m:r>
+                    <m:r>
+                      <a:rPr lang="en-US" i="1">
+                        <a:latin typeface="Cambria Math"/>
+                      </a:rPr>
+                      <m:t>−</m:t>
+                    </m:r>
+                    <m:r>
+                      <a:rPr lang="en-US" i="1">
+                        <a:latin typeface="Cambria Math"/>
+                      </a:rPr>
+                      <m:t>𝑐</m:t>
                     </m:r>
                     <m:sSub>
+                      <m:sSubPr>
+                        <m:ctrlPr>
+                          <a:rPr lang="en-US" i="1">
+                            <a:latin typeface="Cambria Math" panose="02040503050406030204" pitchFamily="18" charset="0"/>
+                          </a:rPr>
+                        </m:ctrlPr>
+                      </m:sSubPr>
                       <m:e>
                         <m:r>
                           <a:rPr lang="en-US" i="1">
                             <a:latin typeface="Cambria Math"/>
                           </a:rPr>
-                          <m:t>s</m:t>
+                          <m:t>𝑠</m:t>
                         </m:r>
                       </m:e>
                       <m:sub>
@@ -17248,23 +17272,43 @@
                   </m:oMath>
                 </a14:m>
                 <a:r>
+                  <a:rPr dirty="0"/>
                   <a:t>가 아니라 </a:t>
                 </a:r>
-                <a14:m xmlns:m="http://schemas.openxmlformats.org/officeDocument/2006/math">
-                  <m:oMath xmlns:mml="http://www.w3.org/1998/Math/MathML">
+                <a14:m>
+                  <m:oMath xmlns:m="http://schemas.openxmlformats.org/officeDocument/2006/math">
                     <m:r>
                       <a:rPr lang="en-US" i="1">
                         <a:latin typeface="Cambria Math"/>
                       </a:rPr>
-                      <m:t>w−c</m:t>
+                      <m:t>𝑤</m:t>
+                    </m:r>
+                    <m:r>
+                      <a:rPr lang="en-US" i="1">
+                        <a:latin typeface="Cambria Math"/>
+                      </a:rPr>
+                      <m:t>−</m:t>
+                    </m:r>
+                    <m:r>
+                      <a:rPr lang="en-US" i="1">
+                        <a:latin typeface="Cambria Math"/>
+                      </a:rPr>
+                      <m:t>𝑐</m:t>
                     </m:r>
                     <m:sSub>
+                      <m:sSubPr>
+                        <m:ctrlPr>
+                          <a:rPr lang="en-US" i="1">
+                            <a:latin typeface="Cambria Math" panose="02040503050406030204" pitchFamily="18" charset="0"/>
+                          </a:rPr>
+                        </m:ctrlPr>
+                      </m:sSubPr>
                       <m:e>
                         <m:r>
                           <a:rPr lang="en-US" i="1">
                             <a:latin typeface="Cambria Math"/>
                           </a:rPr>
-                          <m:t>s</m:t>
+                          <m:t>𝑠</m:t>
                         </m:r>
                       </m:e>
                       <m:sub>
@@ -17280,15 +17324,28 @@
                       <a:rPr lang="en-US" i="1">
                         <a:latin typeface="Cambria Math"/>
                       </a:rPr>
-                      <m:t>+c</m:t>
+                      <m:t>+</m:t>
+                    </m:r>
+                    <m:r>
+                      <a:rPr lang="en-US" i="1">
+                        <a:latin typeface="Cambria Math"/>
+                      </a:rPr>
+                      <m:t>𝑐</m:t>
                     </m:r>
                     <m:sSub>
+                      <m:sSubPr>
+                        <m:ctrlPr>
+                          <a:rPr lang="en-US" i="1">
+                            <a:latin typeface="Cambria Math" panose="02040503050406030204" pitchFamily="18" charset="0"/>
+                          </a:rPr>
+                        </m:ctrlPr>
+                      </m:sSubPr>
                       <m:e>
                         <m:r>
                           <a:rPr lang="en-US" i="1">
                             <a:latin typeface="Cambria Math"/>
                           </a:rPr>
-                          <m:t>t</m:t>
+                          <m:t>𝑡</m:t>
                         </m:r>
                       </m:e>
                       <m:sub>
@@ -17303,29 +17360,56 @@
                   </m:oMath>
                 </a14:m>
                 <a:r>
+                  <a:rPr dirty="0"/>
                   <a:t>다</a:t>
                 </a:r>
               </a:p>
               <a:p>
                 <a:pPr lvl="1"/>
                 <a:r>
+                  <a:rPr dirty="0"/>
                   <a:t>대응: </a:t>
                 </a:r>
-                <a14:m xmlns:m="http://schemas.openxmlformats.org/officeDocument/2006/math">
-                  <m:oMath xmlns:mml="http://www.w3.org/1998/Math/MathML">
+                <a14:m>
+                  <m:oMath xmlns:m="http://schemas.openxmlformats.org/officeDocument/2006/math">
                     <m:r>
                       <a:rPr lang="en-US" i="1">
                         <a:latin typeface="Cambria Math"/>
                       </a:rPr>
-                      <m:t>z↔−c</m:t>
+                      <m:t>𝑧</m:t>
+                    </m:r>
+                    <m:r>
+                      <a:rPr lang="en-US" i="1">
+                        <a:latin typeface="Cambria Math"/>
+                      </a:rPr>
+                      <m:t>↔</m:t>
+                    </m:r>
+                    <m:r>
+                      <a:rPr lang="en-US" i="1">
+                        <a:latin typeface="Cambria Math"/>
+                      </a:rPr>
+                      <m:t>−</m:t>
+                    </m:r>
+                    <m:r>
+                      <a:rPr lang="en-US" i="1">
+                        <a:latin typeface="Cambria Math"/>
+                      </a:rPr>
+                      <m:t>𝑐</m:t>
                     </m:r>
                     <m:sSub>
+                      <m:sSubPr>
+                        <m:ctrlPr>
+                          <a:rPr lang="en-US" i="1">
+                            <a:latin typeface="Cambria Math" panose="02040503050406030204" pitchFamily="18" charset="0"/>
+                          </a:rPr>
+                        </m:ctrlPr>
+                      </m:sSubPr>
                       <m:e>
                         <m:r>
                           <a:rPr lang="en-US" i="1">
                             <a:latin typeface="Cambria Math"/>
                           </a:rPr>
-                          <m:t>t</m:t>
+                          <m:t>𝑡</m:t>
                         </m:r>
                       </m:e>
                       <m:sub>
@@ -17344,27 +17428,58 @@
                       <m:t>,</m:t>
                     </m:r>
                     <m:r>
+                      <m:rPr>
+                        <m:nor/>
+                      </m:rPr>
                       <a:rPr lang="en-US" i="0">
                         <a:latin typeface="Cambria Math"/>
                       </a:rPr>
-                      <m:rPr>
-                        <m:nor/>
-                      </m:rPr>
-                      <m:t> </m:t>
+                      <m:t> </m:t>
                     </m:r>
                     <m:r>
                       <a:rPr lang="en-US" i="1">
                         <a:latin typeface="Cambria Math"/>
                       </a:rPr>
-                      <m:t>r↔w−c</m:t>
+                      <m:t>𝑟</m:t>
+                    </m:r>
+                    <m:r>
+                      <a:rPr lang="en-US" i="1">
+                        <a:latin typeface="Cambria Math"/>
+                      </a:rPr>
+                      <m:t>↔</m:t>
+                    </m:r>
+                    <m:r>
+                      <a:rPr lang="en-US" i="1">
+                        <a:latin typeface="Cambria Math"/>
+                      </a:rPr>
+                      <m:t>𝑤</m:t>
+                    </m:r>
+                    <m:r>
+                      <a:rPr lang="en-US" i="1">
+                        <a:latin typeface="Cambria Math"/>
+                      </a:rPr>
+                      <m:t>−</m:t>
+                    </m:r>
+                    <m:r>
+                      <a:rPr lang="en-US" i="1">
+                        <a:latin typeface="Cambria Math"/>
+                      </a:rPr>
+                      <m:t>𝑐</m:t>
                     </m:r>
                     <m:sSub>
+                      <m:sSubPr>
+                        <m:ctrlPr>
+                          <a:rPr lang="en-US" i="1">
+                            <a:latin typeface="Cambria Math" panose="02040503050406030204" pitchFamily="18" charset="0"/>
+                          </a:rPr>
+                        </m:ctrlPr>
+                      </m:sSubPr>
                       <m:e>
                         <m:r>
                           <a:rPr lang="en-US" i="1">
                             <a:latin typeface="Cambria Math"/>
                           </a:rPr>
-                          <m:t>s</m:t>
+                          <m:t>𝑠</m:t>
                         </m:r>
                       </m:e>
                       <m:sub>
@@ -17380,15 +17495,28 @@
                       <a:rPr lang="en-US" i="1">
                         <a:latin typeface="Cambria Math"/>
                       </a:rPr>
-                      <m:t>+c</m:t>
+                      <m:t>+</m:t>
+                    </m:r>
+                    <m:r>
+                      <a:rPr lang="en-US" i="1">
+                        <a:latin typeface="Cambria Math"/>
+                      </a:rPr>
+                      <m:t>𝑐</m:t>
                     </m:r>
                     <m:sSub>
+                      <m:sSubPr>
+                        <m:ctrlPr>
+                          <a:rPr lang="en-US" i="1">
+                            <a:latin typeface="Cambria Math" panose="02040503050406030204" pitchFamily="18" charset="0"/>
+                          </a:rPr>
+                        </m:ctrlPr>
+                      </m:sSubPr>
                       <m:e>
                         <m:r>
                           <a:rPr lang="en-US" i="1">
                             <a:latin typeface="Cambria Math"/>
                           </a:rPr>
-                          <m:t>t</m:t>
+                          <m:t>𝑡</m:t>
                         </m:r>
                       </m:e>
                       <m:sub>
@@ -17407,27 +17535,46 @@
                       <m:t>,</m:t>
                     </m:r>
                     <m:r>
+                      <m:rPr>
+                        <m:nor/>
+                      </m:rPr>
                       <a:rPr lang="en-US" i="0">
                         <a:latin typeface="Cambria Math"/>
                       </a:rPr>
-                      <m:rPr>
-                        <m:nor/>
-                      </m:rPr>
-                      <m:t> </m:t>
+                      <m:t> </m:t>
                     </m:r>
                     <m:r>
                       <a:rPr lang="en-US" i="1">
                         <a:latin typeface="Cambria Math"/>
                       </a:rPr>
-                      <m:t>α↔2</m:t>
+                      <m:t>𝛼</m:t>
+                    </m:r>
+                    <m:r>
+                      <a:rPr lang="en-US" i="1">
+                        <a:latin typeface="Cambria Math"/>
+                      </a:rPr>
+                      <m:t>↔</m:t>
+                    </m:r>
+                    <m:r>
+                      <a:rPr lang="en-US" i="1">
+                        <a:latin typeface="Cambria Math"/>
+                      </a:rPr>
+                      <m:t>2</m:t>
                     </m:r>
                     <m:sSub>
+                      <m:sSubPr>
+                        <m:ctrlPr>
+                          <a:rPr lang="en-US" i="1">
+                            <a:latin typeface="Cambria Math" panose="02040503050406030204" pitchFamily="18" charset="0"/>
+                          </a:rPr>
+                        </m:ctrlPr>
+                      </m:sSubPr>
                       <m:e>
                         <m:r>
                           <a:rPr lang="en-US" i="1">
                             <a:latin typeface="Cambria Math"/>
                           </a:rPr>
-                          <m:t>γ</m:t>
+                          <m:t>𝛾</m:t>
                         </m:r>
                       </m:e>
                       <m:sub>
@@ -17441,78 +17588,180 @@
                     </m:sSub>
                   </m:oMath>
                 </a14:m>
+                <a:endParaRPr dirty="0"/>
               </a:p>
               <a:p>
-                <a:pPr/>
                 <a:r>
+                  <a:rPr dirty="0"/>
                   <a:t>MakeHint는 </a:t>
                 </a:r>
-                <a14:m xmlns:m="http://schemas.openxmlformats.org/officeDocument/2006/math">
-                  <m:oMath xmlns:mml="http://www.w3.org/1998/Math/MathML">
+                <a14:m>
+                  <m:oMath xmlns:m="http://schemas.openxmlformats.org/officeDocument/2006/math">
                     <m:r>
+                      <m:rPr>
+                        <m:sty m:val="p"/>
+                      </m:rPr>
                       <a:rPr lang="en-US" i="0">
                         <a:latin typeface="Cambria Math"/>
                       </a:rPr>
-                      <m:rPr>
-                        <m:sty m:val="p"/>
-                      </m:rPr>
                       <m:t>HighBits</m:t>
                     </m:r>
                     <m:r>
                       <a:rPr lang="en-US" i="1">
                         <a:latin typeface="Cambria Math"/>
                       </a:rPr>
-                      <m:t>(r+z,α)≠</m:t>
+                      <m:t>(</m:t>
                     </m:r>
                     <m:r>
+                      <a:rPr lang="en-US" i="1">
+                        <a:latin typeface="Cambria Math"/>
+                      </a:rPr>
+                      <m:t>𝑟</m:t>
+                    </m:r>
+                    <m:r>
+                      <a:rPr lang="en-US" i="1">
+                        <a:latin typeface="Cambria Math"/>
+                      </a:rPr>
+                      <m:t>+</m:t>
+                    </m:r>
+                    <m:r>
+                      <a:rPr lang="en-US" i="1">
+                        <a:latin typeface="Cambria Math"/>
+                      </a:rPr>
+                      <m:t>𝑧</m:t>
+                    </m:r>
+                    <m:r>
+                      <a:rPr lang="en-US" i="1">
+                        <a:latin typeface="Cambria Math"/>
+                      </a:rPr>
+                      <m:t>,</m:t>
+                    </m:r>
+                    <m:r>
+                      <a:rPr lang="en-US" i="1">
+                        <a:latin typeface="Cambria Math"/>
+                      </a:rPr>
+                      <m:t>𝛼</m:t>
+                    </m:r>
+                    <m:r>
+                      <a:rPr lang="en-US" i="1">
+                        <a:latin typeface="Cambria Math"/>
+                      </a:rPr>
+                      <m:t>)≠</m:t>
+                    </m:r>
+                    <m:r>
+                      <m:rPr>
+                        <m:sty m:val="p"/>
+                      </m:rPr>
                       <a:rPr lang="en-US" i="0">
                         <a:latin typeface="Cambria Math"/>
                       </a:rPr>
-                      <m:rPr>
-                        <m:sty m:val="p"/>
-                      </m:rPr>
                       <m:t>HighBits</m:t>
                     </m:r>
                     <m:r>
                       <a:rPr lang="en-US" i="1">
                         <a:latin typeface="Cambria Math"/>
                       </a:rPr>
-                      <m:t>(r,α)</m:t>
+                      <m:t>(</m:t>
+                    </m:r>
+                    <m:r>
+                      <a:rPr lang="en-US" i="1">
+                        <a:latin typeface="Cambria Math"/>
+                      </a:rPr>
+                      <m:t>𝑟</m:t>
+                    </m:r>
+                    <m:r>
+                      <a:rPr lang="en-US" i="1">
+                        <a:latin typeface="Cambria Math"/>
+                      </a:rPr>
+                      <m:t>,</m:t>
+                    </m:r>
+                    <m:r>
+                      <a:rPr lang="en-US" i="1">
+                        <a:latin typeface="Cambria Math"/>
+                      </a:rPr>
+                      <m:t>𝛼</m:t>
+                    </m:r>
+                    <m:r>
+                      <a:rPr lang="en-US" i="1">
+                        <a:latin typeface="Cambria Math"/>
+                      </a:rPr>
+                      <m:t>)</m:t>
                     </m:r>
                   </m:oMath>
                 </a14:m>
                 <a:r>
+                  <a:rPr dirty="0"/>
                   <a:t>인지만 1비트로 답한다</a:t>
                 </a:r>
               </a:p>
               <a:p>
-                <a:pPr/>
                 <a:r>
-                  <a:t>겉보기 모순: 캐리는 {−1, 0, +1} 세 값인데 h는 {0, 1} 두 값뿐이다</a:t>
+                  <a:rPr lang="ko-KR" altLang="en-US" dirty="0"/>
+                  <a:t>문제</a:t>
+                </a:r>
+                <a:r>
+                  <a:rPr dirty="0"/>
+                  <a:t>: 캐리는 {−1, 0, +1} 세 값인데 h는 {0, 1} 두 값뿐이다</a:t>
                 </a:r>
               </a:p>
               <a:p>
-                <a:pPr/>
                 <a:r>
-                  <a:rPr/>
-                  <a:t>해소: h는 “바뀌었는가”만 싣고, 방향은 검증자가 이미 가진 </a:t>
+                  <a:rPr lang="ko-KR" altLang="en-US" dirty="0"/>
+                  <a:t>아이디어</a:t>
                 </a:r>
                 <a:r>
-                  <a:rPr/>
-                  <a:t>r</a:t>
+                  <a:rPr dirty="0"/>
+                  <a:t>: h는 “바뀌었는가”만 싣고, 방향은 검증자가 이미 가진 r</a:t>
                 </a:r>
                 <a:r>
-                  <a:rPr baseline="-25000"/>
+                  <a:rPr baseline="-25000" dirty="0"/>
                   <a:t>0</a:t>
                 </a:r>
                 <a:r>
-                  <a:rPr/>
+                  <a:rPr dirty="0"/>
                   <a:t>의 부호에서 읽는다</a:t>
                 </a:r>
               </a:p>
             </p:txBody>
           </p:sp>
         </mc:Choice>
+        <mc:Fallback>
+          <p:sp>
+            <p:nvSpPr>
+              <p:cNvPr id="3" name="Content Placeholder 2"/>
+              <p:cNvSpPr>
+                <a:spLocks noGrp="1" noRot="1" noChangeAspect="1" noMove="1" noResize="1" noEditPoints="1" noAdjustHandles="1" noChangeArrowheads="1" noChangeShapeType="1" noTextEdit="1"/>
+              </p:cNvSpPr>
+              <p:nvPr>
+                <p:ph idx="1"/>
+              </p:nvPr>
+            </p:nvSpPr>
+            <p:spPr>
+              <a:xfrm>
+                <a:off x="838200" y="1295322"/>
+                <a:ext cx="10515600" cy="2900000"/>
+              </a:xfrm>
+              <a:blipFill>
+                <a:blip r:embed="rId2"/>
+                <a:stretch>
+                  <a:fillRect l="-406"/>
+                </a:stretch>
+              </a:blipFill>
+            </p:spPr>
+            <p:txBody>
+              <a:bodyPr/>
+              <a:lstStyle/>
+              <a:p>
+                <a:r>
+                  <a:rPr lang="ko-KR" altLang="en-US">
+                    <a:noFill/>
+                  </a:rPr>
+                  <a:t> </a:t>
+                </a:r>
+              </a:p>
+            </p:txBody>
+          </p:sp>
+        </mc:Fallback>
       </mc:AlternateContent>
       <p:sp>
         <p:nvSpPr>
@@ -17537,7 +17786,7 @@
           <a:p>
             <a:fld id="{4438A2D4-3867-488E-A04E-7BFFCAED45A6}" type="slidenum">
               <a:rPr lang="ko-KR" altLang="en-US" smtClean="0"/>
-              <a:t>‹#›</a:t>
+              <a:t>3</a:t>
             </a:fld>
             <a:endParaRPr lang="ko-KR" altLang="en-US" dirty="0"/>
           </a:p>
@@ -17549,7 +17798,13 @@
           <p:cNvGraphicFramePr>
             <a:graphicFrameLocks noGrp="1"/>
           </p:cNvGraphicFramePr>
-          <p:nvPr/>
+          <p:nvPr>
+            <p:extLst>
+              <p:ext uri="{D42A27DB-BD31-4B8C-83A1-F6EECF244321}">
+                <p14:modId xmlns:p14="http://schemas.microsoft.com/office/powerpoint/2010/main" val="3083807576"/>
+              </p:ext>
+            </p:extLst>
+          </p:nvPr>
         </p:nvGraphicFramePr>
         <p:xfrm>
           <a:off x="838200" y="4100000"/>
@@ -17562,9 +17817,27 @@
                 <a:tableStyleId>{5A111915-BE36-4E01-A7E5-04B1672EAD32}</a:tableStyleId>
               </a:tblPr>
               <a:tblGrid>
-                <a:gridCol w="3505200"/>
-                <a:gridCol w="3505200"/>
-                <a:gridCol w="3505200"/>
+                <a:gridCol w="3505200">
+                  <a:extLst>
+                    <a:ext uri="{9D8B030D-6E8A-4147-A177-3AD203B41FA5}">
+                      <a16:colId xmlns:a16="http://schemas.microsoft.com/office/drawing/2014/main" val="20000"/>
+                    </a:ext>
+                  </a:extLst>
+                </a:gridCol>
+                <a:gridCol w="3505200">
+                  <a:extLst>
+                    <a:ext uri="{9D8B030D-6E8A-4147-A177-3AD203B41FA5}">
+                      <a16:colId xmlns:a16="http://schemas.microsoft.com/office/drawing/2014/main" val="20001"/>
+                    </a:ext>
+                  </a:extLst>
+                </a:gridCol>
+                <a:gridCol w="3505200">
+                  <a:extLst>
+                    <a:ext uri="{9D8B030D-6E8A-4147-A177-3AD203B41FA5}">
+                      <a16:colId xmlns:a16="http://schemas.microsoft.com/office/drawing/2014/main" val="20002"/>
+                    </a:ext>
+                  </a:extLst>
+                </a:gridCol>
               </a:tblGrid>
               <a:tr h="375000">
                 <a:tc>
@@ -17574,7 +17847,7 @@
                     <a:p>
                       <a:pPr algn="ctr"/>
                       <a:r>
-                        <a:rPr sz="1800" b="1"/>
+                        <a:rPr sz="1800" b="1" dirty="0"/>
                         <a:t>h</a:t>
                       </a:r>
                     </a:p>
@@ -17625,15 +17898,15 @@
                     <a:p>
                       <a:pPr algn="ctr"/>
                       <a:r>
-                        <a:rPr sz="1800" b="1"/>
+                        <a:rPr sz="1800" b="1" dirty="0"/>
                         <a:t>r</a:t>
                       </a:r>
                       <a:r>
-                        <a:rPr sz="1800" b="1" baseline="-25000"/>
+                        <a:rPr sz="1800" b="1" baseline="-25000" dirty="0"/>
                         <a:t>0</a:t>
                       </a:r>
                       <a:r>
-                        <a:rPr sz="1800" b="1"/>
+                        <a:rPr sz="1800" b="1" dirty="0"/>
                         <a:t> 조건</a:t>
                       </a:r>
                     </a:p>
@@ -17684,7 +17957,7 @@
                     <a:p>
                       <a:pPr algn="ctr"/>
                       <a:r>
-                        <a:rPr sz="1800" b="1"/>
+                        <a:rPr sz="1800" b="1" dirty="0"/>
                         <a:t>반환값</a:t>
                       </a:r>
                     </a:p>
@@ -17728,6 +18001,11 @@
                     </a:lnB>
                   </a:tcPr>
                 </a:tc>
+                <a:extLst>
+                  <a:ext uri="{0D108BD9-81ED-4DB2-BD59-A6C34878D82A}">
+                    <a16:rowId xmlns:a16="http://schemas.microsoft.com/office/drawing/2014/main" val="10000"/>
+                  </a:ext>
+                </a:extLst>
               </a:tr>
               <a:tr h="375000">
                 <a:tc>
@@ -17737,7 +18015,7 @@
                     <a:p>
                       <a:pPr algn="ctr"/>
                       <a:r>
-                        <a:rPr sz="1800"/>
+                        <a:rPr sz="1800" dirty="0"/>
                         <a:t>0</a:t>
                       </a:r>
                     </a:p>
@@ -17788,7 +18066,7 @@
                     <a:p>
                       <a:pPr algn="ctr"/>
                       <a:r>
-                        <a:rPr sz="1800"/>
+                        <a:rPr sz="1800" dirty="0"/>
                         <a:t>—</a:t>
                       </a:r>
                     </a:p>
@@ -17839,11 +18117,11 @@
                     <a:p>
                       <a:pPr algn="ctr"/>
                       <a:r>
-                        <a:rPr sz="1800"/>
+                        <a:rPr sz="1800" dirty="0"/>
                         <a:t>r</a:t>
                       </a:r>
                       <a:r>
-                        <a:rPr sz="1800" baseline="-25000"/>
+                        <a:rPr sz="1800" baseline="-25000" dirty="0"/>
                         <a:t>1</a:t>
                       </a:r>
                     </a:p>
@@ -17887,6 +18165,11 @@
                     </a:lnB>
                   </a:tcPr>
                 </a:tc>
+                <a:extLst>
+                  <a:ext uri="{0D108BD9-81ED-4DB2-BD59-A6C34878D82A}">
+                    <a16:rowId xmlns:a16="http://schemas.microsoft.com/office/drawing/2014/main" val="10001"/>
+                  </a:ext>
+                </a:extLst>
               </a:tr>
               <a:tr h="375000">
                 <a:tc>
@@ -17896,7 +18179,7 @@
                     <a:p>
                       <a:pPr algn="ctr"/>
                       <a:r>
-                        <a:rPr sz="1800"/>
+                        <a:rPr sz="1800" dirty="0"/>
                         <a:t>1</a:t>
                       </a:r>
                     </a:p>
@@ -17947,15 +18230,15 @@
                     <a:p>
                       <a:pPr algn="ctr"/>
                       <a:r>
-                        <a:rPr sz="1800"/>
+                        <a:rPr sz="1800" dirty="0"/>
                         <a:t>r</a:t>
                       </a:r>
                       <a:r>
-                        <a:rPr sz="1800" baseline="-25000"/>
+                        <a:rPr sz="1800" baseline="-25000" dirty="0"/>
                         <a:t>0</a:t>
                       </a:r>
                       <a:r>
-                        <a:rPr sz="1800"/>
+                        <a:rPr sz="1800" dirty="0"/>
                         <a:t> &gt; 0</a:t>
                       </a:r>
                     </a:p>
@@ -18006,15 +18289,15 @@
                     <a:p>
                       <a:pPr algn="ctr"/>
                       <a:r>
-                        <a:rPr sz="1800"/>
+                        <a:rPr sz="1800" dirty="0"/>
                         <a:t>r</a:t>
                       </a:r>
                       <a:r>
-                        <a:rPr sz="1800" baseline="-25000"/>
+                        <a:rPr sz="1800" baseline="-25000" dirty="0"/>
                         <a:t>1</a:t>
                       </a:r>
                       <a:r>
-                        <a:rPr sz="1800"/>
+                        <a:rPr sz="1800" dirty="0"/>
                         <a:t> + 1 mod m</a:t>
                       </a:r>
                     </a:p>
@@ -18058,6 +18341,11 @@
                     </a:lnB>
                   </a:tcPr>
                 </a:tc>
+                <a:extLst>
+                  <a:ext uri="{0D108BD9-81ED-4DB2-BD59-A6C34878D82A}">
+                    <a16:rowId xmlns:a16="http://schemas.microsoft.com/office/drawing/2014/main" val="10002"/>
+                  </a:ext>
+                </a:extLst>
               </a:tr>
               <a:tr h="375000">
                 <a:tc>
@@ -18067,7 +18355,7 @@
                     <a:p>
                       <a:pPr algn="ctr"/>
                       <a:r>
-                        <a:rPr sz="1800"/>
+                        <a:rPr sz="1800" dirty="0"/>
                         <a:t>1</a:t>
                       </a:r>
                     </a:p>
@@ -18118,15 +18406,15 @@
                     <a:p>
                       <a:pPr algn="ctr"/>
                       <a:r>
-                        <a:rPr sz="1800"/>
+                        <a:rPr sz="1800" dirty="0"/>
                         <a:t>r</a:t>
                       </a:r>
                       <a:r>
-                        <a:rPr sz="1800" baseline="-25000"/>
+                        <a:rPr sz="1800" baseline="-25000" dirty="0"/>
                         <a:t>0</a:t>
                       </a:r>
                       <a:r>
-                        <a:rPr sz="1800"/>
+                        <a:rPr sz="1800" dirty="0"/>
                         <a:t> ≤ 0</a:t>
                       </a:r>
                     </a:p>
@@ -18177,15 +18465,15 @@
                     <a:p>
                       <a:pPr algn="ctr"/>
                       <a:r>
-                        <a:rPr sz="1800"/>
+                        <a:rPr sz="1800" dirty="0"/>
                         <a:t>r</a:t>
                       </a:r>
                       <a:r>
-                        <a:rPr sz="1800" baseline="-25000"/>
+                        <a:rPr sz="1800" baseline="-25000" dirty="0"/>
                         <a:t>1</a:t>
                       </a:r>
                       <a:r>
-                        <a:rPr sz="1800"/>
+                        <a:rPr sz="1800" dirty="0"/>
                         <a:t> − 1 mod m</a:t>
                       </a:r>
                     </a:p>
@@ -18229,6 +18517,11 @@
                     </a:lnB>
                   </a:tcPr>
                 </a:tc>
+                <a:extLst>
+                  <a:ext uri="{0D108BD9-81ED-4DB2-BD59-A6C34878D82A}">
+                    <a16:rowId xmlns:a16="http://schemas.microsoft.com/office/drawing/2014/main" val="10003"/>
+                  </a:ext>
+                </a:extLst>
               </a:tr>
             </a:tbl>
           </a:graphicData>
@@ -18608,7 +18901,7 @@
           <a:p>
             <a:fld id="{4438A2D4-3867-488E-A04E-7BFFCAED45A6}" type="slidenum">
               <a:rPr lang="ko-KR" altLang="en-US" smtClean="0"/>
-              <a:t>27</a:t>
+              <a:t>30</a:t>
             </a:fld>
             <a:endParaRPr lang="ko-KR" altLang="en-US" dirty="0"/>
           </a:p>
@@ -20354,7 +20647,7 @@
           <a:p>
             <a:fld id="{4438A2D4-3867-488E-A04E-7BFFCAED45A6}" type="slidenum">
               <a:rPr lang="ko-KR" altLang="en-US" smtClean="0"/>
-              <a:t>28</a:t>
+              <a:t>31</a:t>
             </a:fld>
             <a:endParaRPr lang="ko-KR" altLang="en-US" dirty="0"/>
           </a:p>
@@ -20623,7 +20916,7 @@
           <a:p>
             <a:fld id="{4438A2D4-3867-488E-A04E-7BFFCAED45A6}" type="slidenum">
               <a:rPr lang="ko-KR" altLang="en-US" smtClean="0"/>
-              <a:t>29</a:t>
+              <a:t>32</a:t>
             </a:fld>
             <a:endParaRPr lang="ko-KR" altLang="en-US" dirty="0"/>
           </a:p>
@@ -21552,7 +21845,7 @@
           <a:p>
             <a:fld id="{4438A2D4-3867-488E-A04E-7BFFCAED45A6}" type="slidenum">
               <a:rPr lang="ko-KR" altLang="en-US" smtClean="0"/>
-              <a:t>30</a:t>
+              <a:t>33</a:t>
             </a:fld>
             <a:endParaRPr lang="ko-KR" altLang="en-US" dirty="0"/>
           </a:p>
@@ -22278,7 +22571,7 @@
           <a:p>
             <a:fld id="{4438A2D4-3867-488E-A04E-7BFFCAED45A6}" type="slidenum">
               <a:rPr lang="ko-KR" altLang="en-US" smtClean="0"/>
-              <a:t>31</a:t>
+              <a:t>34</a:t>
             </a:fld>
             <a:endParaRPr lang="ko-KR" altLang="en-US" dirty="0"/>
           </a:p>
@@ -23245,7 +23538,7 @@
           <a:p>
             <a:fld id="{4438A2D4-3867-488E-A04E-7BFFCAED45A6}" type="slidenum">
               <a:rPr lang="ko-KR" altLang="en-US" smtClean="0"/>
-              <a:t>32</a:t>
+              <a:t>35</a:t>
             </a:fld>
             <a:endParaRPr lang="ko-KR" altLang="en-US" dirty="0"/>
           </a:p>
@@ -24499,7 +24792,7 @@
 </file>
 
 <file path=ppt/slides/slide4.xml><?xml version="1.0" encoding="utf-8"?>
-<p:sld xmlns:a="http://schemas.openxmlformats.org/drawingml/2006/main" xmlns:p="http://schemas.openxmlformats.org/presentationml/2006/main" xmlns:r="http://schemas.openxmlformats.org/officeDocument/2006/relationships">
+<p:sld xmlns:a="http://schemas.openxmlformats.org/drawingml/2006/main" xmlns:r="http://schemas.openxmlformats.org/officeDocument/2006/relationships" xmlns:p="http://schemas.openxmlformats.org/presentationml/2006/main">
   <p:cSld>
     <p:spTree>
       <p:nvGrpSpPr>
@@ -24507,7 +24800,14 @@
         <p:cNvGrpSpPr/>
         <p:nvPr/>
       </p:nvGrpSpPr>
-      <p:grpSpPr/>
+      <p:grpSpPr>
+        <a:xfrm>
+          <a:off x="0" y="0"/>
+          <a:ext cx="0" cy="0"/>
+          <a:chOff x="0" y="0"/>
+          <a:chExt cx="0" cy="0"/>
+        </a:xfrm>
+      </p:grpSpPr>
       <p:sp>
         <p:nvSpPr>
           <p:cNvPr id="2" name="Title 1"/>
@@ -24529,6 +24829,7 @@
           <a:lstStyle/>
           <a:p>
             <a:r>
+              <a:rPr dirty="0"/>
               <a:t>전제가 깨지는 지점: r = 19, 20</a:t>
             </a:r>
           </a:p>
@@ -24553,129 +24854,215 @@
               </a:xfrm>
             </p:spPr>
             <p:txBody>
-              <a:bodyPr wrap="square"/>
+              <a:bodyPr wrap="square">
+                <a:normAutofit lnSpcReduction="10000"/>
+              </a:bodyPr>
               <a:lstStyle/>
               <a:p>
-                <a:pPr/>
                 <a:r>
+                  <a:rPr dirty="0"/>
                   <a:t>성립해야 할 전제: 어떤 r에서도 </a:t>
                 </a:r>
-                <a14:m xmlns:m="http://schemas.openxmlformats.org/officeDocument/2006/math">
-                  <m:oMath xmlns:mml="http://www.w3.org/1998/Math/MathML">
+                <a14:m>
+                  <m:oMath xmlns:m="http://schemas.openxmlformats.org/officeDocument/2006/math">
                     <m:r>
                       <a:rPr lang="en-US" i="1">
                         <a:latin typeface="Cambria Math"/>
                       </a:rPr>
-                      <m:t>+z</m:t>
-                    </m:r>
-                  </m:oMath>
-                </a14:m>
-                <a:r>
-                  <a:t>와 </a:t>
-                </a:r>
-                <a14:m xmlns:m="http://schemas.openxmlformats.org/officeDocument/2006/math">
-                  <m:oMath xmlns:mml="http://www.w3.org/1998/Math/MathML">
-                    <m:r>
-                      <a:rPr lang="en-US" i="1">
-                        <a:latin typeface="Cambria Math"/>
-                      </a:rPr>
-                      <m:t>−z</m:t>
-                    </m:r>
-                  </m:oMath>
-                </a14:m>
-                <a:r>
-                  <a:t> 중 최대 한 방향으로만 HighBits가 바뀐다</a:t>
-                </a:r>
-              </a:p>
-              <a:p>
-                <a:pPr/>
-                <a:r>
-                  <a:t>그런데 </a:t>
-                </a:r>
-                <a14:m xmlns:m="http://schemas.openxmlformats.org/officeDocument/2006/math">
-                  <m:oMath xmlns:mml="http://www.w3.org/1998/Math/MathML">
-                    <m:r>
-                      <a:rPr lang="en-US" i="1">
-                        <a:latin typeface="Cambria Math"/>
-                      </a:rPr>
-                      <m:t>q=21,</m:t>
-                    </m:r>
-                    <m:r>
-                      <a:rPr lang="en-US" i="0">
-                        <a:latin typeface="Cambria Math"/>
-                      </a:rPr>
-                      <m:rPr>
-                        <m:nor/>
-                      </m:rPr>
-                      <m:t> </m:t>
+                      <m:t>+</m:t>
                     </m:r>
                     <m:r>
                       <a:rPr lang="en-US" i="1">
                         <a:latin typeface="Cambria Math"/>
                       </a:rPr>
-                      <m:t>α=4,</m:t>
+                      <m:t>𝑧</m:t>
                     </m:r>
+                  </m:oMath>
+                </a14:m>
+                <a:r>
+                  <a:rPr dirty="0"/>
+                  <a:t>와 </a:t>
+                </a:r>
+                <a14:m>
+                  <m:oMath xmlns:m="http://schemas.openxmlformats.org/officeDocument/2006/math">
                     <m:r>
-                      <a:rPr lang="en-US" i="0">
+                      <a:rPr lang="en-US" i="1">
                         <a:latin typeface="Cambria Math"/>
                       </a:rPr>
-                      <m:rPr>
-                        <m:nor/>
-                      </m:rPr>
-                      <m:t> </m:t>
+                      <m:t>−</m:t>
                     </m:r>
                     <m:r>
                       <a:rPr lang="en-US" i="1">
                         <a:latin typeface="Cambria Math"/>
                       </a:rPr>
-                      <m:t>m=(q−1)/α=5</m:t>
+                      <m:t>𝑧</m:t>
                     </m:r>
                   </m:oMath>
                 </a14:m>
                 <a:r>
-                  <a:t>에서는 </a:t>
+                  <a:rPr dirty="0"/>
+                  <a:t> 중 최대 한 방향으로만 HighBits가 바뀐다</a:t>
                 </a:r>
-                <a14:m xmlns:m="http://schemas.openxmlformats.org/officeDocument/2006/math">
-                  <m:oMath xmlns:mml="http://www.w3.org/1998/Math/MathML">
+              </a:p>
+              <a:p>
+                <a:r>
+                  <a:rPr dirty="0"/>
+                  <a:t>그런데 </a:t>
+                </a:r>
+                <a14:m>
+                  <m:oMath xmlns:m="http://schemas.openxmlformats.org/officeDocument/2006/math">
                     <m:r>
                       <a:rPr lang="en-US" i="1">
                         <a:latin typeface="Cambria Math"/>
                       </a:rPr>
-                      <m:t>mα=20=q−1</m:t>
+                      <m:t>𝑞</m:t>
+                    </m:r>
+                    <m:r>
+                      <a:rPr lang="en-US" i="1">
+                        <a:latin typeface="Cambria Math"/>
+                      </a:rPr>
+                      <m:t>=21,</m:t>
+                    </m:r>
+                    <m:r>
+                      <m:rPr>
+                        <m:nor/>
+                      </m:rPr>
+                      <a:rPr lang="en-US" i="0">
+                        <a:latin typeface="Cambria Math"/>
+                      </a:rPr>
+                      <m:t> </m:t>
+                    </m:r>
+                    <m:r>
+                      <a:rPr lang="en-US" i="1">
+                        <a:latin typeface="Cambria Math"/>
+                      </a:rPr>
+                      <m:t>𝛼</m:t>
+                    </m:r>
+                    <m:r>
+                      <a:rPr lang="en-US" i="1">
+                        <a:latin typeface="Cambria Math"/>
+                      </a:rPr>
+                      <m:t>=4,</m:t>
+                    </m:r>
+                    <m:r>
+                      <m:rPr>
+                        <m:nor/>
+                      </m:rPr>
+                      <a:rPr lang="en-US" i="0">
+                        <a:latin typeface="Cambria Math"/>
+                      </a:rPr>
+                      <m:t> </m:t>
+                    </m:r>
+                    <m:r>
+                      <a:rPr lang="en-US" i="1">
+                        <a:latin typeface="Cambria Math"/>
+                      </a:rPr>
+                      <m:t>𝑚</m:t>
+                    </m:r>
+                    <m:r>
+                      <a:rPr lang="en-US" i="1">
+                        <a:latin typeface="Cambria Math"/>
+                      </a:rPr>
+                      <m:t>=(</m:t>
+                    </m:r>
+                    <m:r>
+                      <a:rPr lang="en-US" i="1">
+                        <a:latin typeface="Cambria Math"/>
+                      </a:rPr>
+                      <m:t>𝑞</m:t>
+                    </m:r>
+                    <m:r>
+                      <a:rPr lang="en-US" i="1">
+                        <a:latin typeface="Cambria Math"/>
+                      </a:rPr>
+                      <m:t>−1)/</m:t>
+                    </m:r>
+                    <m:r>
+                      <a:rPr lang="en-US" i="1">
+                        <a:latin typeface="Cambria Math"/>
+                      </a:rPr>
+                      <m:t>𝛼</m:t>
+                    </m:r>
+                    <m:r>
+                      <a:rPr lang="en-US" i="1">
+                        <a:latin typeface="Cambria Math"/>
+                      </a:rPr>
+                      <m:t>=5</m:t>
                     </m:r>
                   </m:oMath>
                 </a14:m>
                 <a:r>
-                  <a:rPr/>
-                  <a:t> — </a:t>
+                  <a:rPr dirty="0"/>
+                  <a:t>에서는 </a:t>
+                </a:r>
+                <a14:m>
+                  <m:oMath xmlns:m="http://schemas.openxmlformats.org/officeDocument/2006/math">
+                    <m:r>
+                      <a:rPr lang="en-US" i="1">
+                        <a:latin typeface="Cambria Math"/>
+                      </a:rPr>
+                      <m:t>𝑚</m:t>
+                    </m:r>
+                    <m:r>
+                      <a:rPr lang="en-US" i="1">
+                        <a:latin typeface="Cambria Math"/>
+                      </a:rPr>
+                      <m:t>𝛼</m:t>
+                    </m:r>
+                    <m:r>
+                      <a:rPr lang="en-US" i="1">
+                        <a:latin typeface="Cambria Math"/>
+                      </a:rPr>
+                      <m:t>=20=</m:t>
+                    </m:r>
+                    <m:r>
+                      <a:rPr lang="en-US" i="1">
+                        <a:latin typeface="Cambria Math"/>
+                      </a:rPr>
+                      <m:t>𝑞</m:t>
+                    </m:r>
+                    <m:r>
+                      <a:rPr lang="en-US" i="1">
+                        <a:latin typeface="Cambria Math"/>
+                      </a:rPr>
+                      <m:t>−1</m:t>
+                    </m:r>
+                  </m:oMath>
+                </a14:m>
+                <a:r>
+                  <a:rPr dirty="0"/>
+                  <a:t> — r</a:t>
                 </a:r>
                 <a:r>
-                  <a:rPr/>
-                  <a:t>r</a:t>
-                </a:r>
-                <a:r>
-                  <a:rPr baseline="-25000"/>
+                  <a:rPr baseline="-25000" dirty="0"/>
                   <a:t>1</a:t>
                 </a:r>
                 <a:r>
-                  <a:rPr/>
+                  <a:rPr dirty="0"/>
                   <a:t>이 넘어가는 지점과 값이 0으로 감기는 지점이 겹친다</a:t>
                 </a:r>
               </a:p>
               <a:p>
-                <a:pPr/>
                 <a:r>
+                  <a:rPr dirty="0"/>
                   <a:t>조정 전 Decompose는 </a:t>
                 </a:r>
-                <a14:m xmlns:m="http://schemas.openxmlformats.org/officeDocument/2006/math">
-                  <m:oMath xmlns:mml="http://www.w3.org/1998/Math/MathML">
+                <a14:m>
+                  <m:oMath xmlns:m="http://schemas.openxmlformats.org/officeDocument/2006/math">
                     <m:sSub>
+                      <m:sSubPr>
+                        <m:ctrlPr>
+                          <a:rPr lang="en-US">
+                            <a:latin typeface="Cambria Math" panose="02040503050406030204" pitchFamily="18" charset="0"/>
+                          </a:rPr>
+                        </m:ctrlPr>
+                      </m:sSubPr>
                       <m:e>
                         <m:r>
                           <a:rPr lang="en-US" i="1">
                             <a:latin typeface="Cambria Math"/>
                           </a:rPr>
-                          <m:t>r</m:t>
+                          <m:t>𝑟</m:t>
                         </m:r>
                       </m:e>
                       <m:sub>
@@ -24691,15 +25078,34 @@
                       <a:rPr lang="en-US" i="1">
                         <a:latin typeface="Cambria Math"/>
                       </a:rPr>
-                      <m:t>=(r−</m:t>
+                      <m:t>=(</m:t>
+                    </m:r>
+                    <m:r>
+                      <a:rPr lang="en-US" i="1">
+                        <a:latin typeface="Cambria Math"/>
+                      </a:rPr>
+                      <m:t>𝑟</m:t>
+                    </m:r>
+                    <m:r>
+                      <a:rPr lang="en-US" i="1">
+                        <a:latin typeface="Cambria Math"/>
+                      </a:rPr>
+                      <m:t>−</m:t>
                     </m:r>
                     <m:sSub>
+                      <m:sSubPr>
+                        <m:ctrlPr>
+                          <a:rPr lang="en-US" i="1">
+                            <a:latin typeface="Cambria Math" panose="02040503050406030204" pitchFamily="18" charset="0"/>
+                          </a:rPr>
+                        </m:ctrlPr>
+                      </m:sSubPr>
                       <m:e>
                         <m:r>
                           <a:rPr lang="en-US" i="1">
                             <a:latin typeface="Cambria Math"/>
                           </a:rPr>
-                          <m:t>r</m:t>
+                          <m:t>𝑟</m:t>
                         </m:r>
                       </m:e>
                       <m:sub>
@@ -24715,22 +25121,36 @@
                       <a:rPr lang="en-US" i="1">
                         <a:latin typeface="Cambria Math"/>
                       </a:rPr>
-                      <m:t>)/α</m:t>
+                      <m:t>)/</m:t>
+                    </m:r>
+                    <m:r>
+                      <a:rPr lang="en-US" i="1">
+                        <a:latin typeface="Cambria Math"/>
+                      </a:rPr>
+                      <m:t>𝛼</m:t>
                     </m:r>
                   </m:oMath>
                 </a14:m>
                 <a:r>
+                  <a:rPr dirty="0"/>
                   <a:t>를 그대로 쓰므로 r = 19, 20만 </a:t>
                 </a:r>
-                <a14:m xmlns:m="http://schemas.openxmlformats.org/officeDocument/2006/math">
-                  <m:oMath xmlns:mml="http://www.w3.org/1998/Math/MathML">
+                <a14:m>
+                  <m:oMath xmlns:m="http://schemas.openxmlformats.org/officeDocument/2006/math">
                     <m:sSub>
+                      <m:sSubPr>
+                        <m:ctrlPr>
+                          <a:rPr lang="en-US">
+                            <a:latin typeface="Cambria Math" panose="02040503050406030204" pitchFamily="18" charset="0"/>
+                          </a:rPr>
+                        </m:ctrlPr>
+                      </m:sSubPr>
                       <m:e>
                         <m:r>
                           <a:rPr lang="en-US" i="1">
                             <a:latin typeface="Cambria Math"/>
                           </a:rPr>
-                          <m:t>r</m:t>
+                          <m:t>𝑟</m:t>
                         </m:r>
                       </m:e>
                       <m:sub>
@@ -24749,27 +25169,40 @@
                       <m:t>=5</m:t>
                     </m:r>
                     <m:r>
+                      <m:rPr>
+                        <m:nor/>
+                      </m:rPr>
                       <a:rPr lang="en-US" i="0">
                         <a:latin typeface="Cambria Math"/>
                       </a:rPr>
-                      <m:rPr>
-                        <m:nor/>
-                      </m:rPr>
-                      <m:t> </m:t>
+                      <m:t> </m:t>
                     </m:r>
                     <m:r>
                       <a:rPr lang="en-US" i="1">
                         <a:latin typeface="Cambria Math"/>
                       </a:rPr>
-                      <m:t>(=m)</m:t>
+                      <m:t>(=</m:t>
+                    </m:r>
+                    <m:r>
+                      <a:rPr lang="en-US" i="1">
+                        <a:latin typeface="Cambria Math"/>
+                      </a:rPr>
+                      <m:t>𝑚</m:t>
+                    </m:r>
+                    <m:r>
+                      <a:rPr lang="en-US" i="1">
+                        <a:latin typeface="Cambria Math"/>
+                      </a:rPr>
+                      <m:t>)</m:t>
                     </m:r>
                   </m:oMath>
                 </a14:m>
                 <a:r>
+                  <a:rPr dirty="0"/>
                   <a:t>을 받는데, </a:t>
                 </a:r>
-                <a14:m xmlns:m="http://schemas.openxmlformats.org/officeDocument/2006/math">
-                  <m:oMath xmlns:mml="http://www.w3.org/1998/Math/MathML">
+                <a14:m>
+                  <m:oMath xmlns:m="http://schemas.openxmlformats.org/officeDocument/2006/math">
                     <m:r>
                       <a:rPr lang="en-US" i="1">
                         <a:latin typeface="Cambria Math"/>
@@ -24777,13 +25210,13 @@
                       <m:t>5≡0</m:t>
                     </m:r>
                     <m:r>
+                      <m:rPr>
+                        <m:nor/>
+                      </m:rPr>
                       <a:rPr lang="en-US" i="0">
                         <a:latin typeface="Cambria Math"/>
                       </a:rPr>
-                      <m:rPr>
-                        <m:nor/>
-                      </m:rPr>
-                      <m:t> </m:t>
+                      <m:t> </m:t>
                     </m:r>
                     <m:r>
                       <a:rPr lang="en-US" i="1">
@@ -24792,38 +25225,82 @@
                       <m:t>(</m:t>
                     </m:r>
                     <m:r>
+                      <m:rPr>
+                        <m:sty m:val="p"/>
+                      </m:rPr>
                       <a:rPr lang="en-US" i="0">
                         <a:latin typeface="Cambria Math"/>
                       </a:rPr>
-                      <m:rPr>
-                        <m:sty m:val="p"/>
-                      </m:rPr>
                       <m:t>mod</m:t>
                     </m:r>
                     <m:r>
+                      <m:rPr>
+                        <m:nor/>
+                      </m:rPr>
                       <a:rPr lang="en-US" i="0">
                         <a:latin typeface="Cambria Math"/>
                       </a:rPr>
-                      <m:rPr>
-                        <m:nor/>
-                      </m:rPr>
-                      <m:t> </m:t>
+                      <m:t> </m:t>
                     </m:r>
                     <m:r>
                       <a:rPr lang="en-US" i="1">
                         <a:latin typeface="Cambria Math"/>
                       </a:rPr>
-                      <m:t>m)</m:t>
+                      <m:t>𝑚</m:t>
+                    </m:r>
+                    <m:r>
+                      <a:rPr lang="en-US" i="1">
+                        <a:latin typeface="Cambria Math"/>
+                      </a:rPr>
+                      <m:t>)</m:t>
                     </m:r>
                   </m:oMath>
                 </a14:m>
                 <a:r>
+                  <a:rPr dirty="0"/>
                   <a:t>이라 제 번호로 돌아온 것을 “바뀜”으로 오인한다</a:t>
                 </a:r>
               </a:p>
             </p:txBody>
           </p:sp>
         </mc:Choice>
+        <mc:Fallback>
+          <p:sp>
+            <p:nvSpPr>
+              <p:cNvPr id="3" name="Content Placeholder 2"/>
+              <p:cNvSpPr>
+                <a:spLocks noGrp="1" noRot="1" noChangeAspect="1" noMove="1" noResize="1" noEditPoints="1" noAdjustHandles="1" noChangeArrowheads="1" noChangeShapeType="1" noTextEdit="1"/>
+              </p:cNvSpPr>
+              <p:nvPr>
+                <p:ph idx="1"/>
+              </p:nvPr>
+            </p:nvSpPr>
+            <p:spPr>
+              <a:xfrm>
+                <a:off x="838200" y="1295322"/>
+                <a:ext cx="10515600" cy="2300000"/>
+              </a:xfrm>
+              <a:blipFill>
+                <a:blip r:embed="rId2"/>
+                <a:stretch>
+                  <a:fillRect l="-406" b="-529"/>
+                </a:stretch>
+              </a:blipFill>
+            </p:spPr>
+            <p:txBody>
+              <a:bodyPr/>
+              <a:lstStyle/>
+              <a:p>
+                <a:r>
+                  <a:rPr lang="ko-KR" altLang="en-US">
+                    <a:noFill/>
+                  </a:rPr>
+                  <a:t> </a:t>
+                </a:r>
+              </a:p>
+            </p:txBody>
+          </p:sp>
+        </mc:Fallback>
       </mc:AlternateContent>
       <p:sp>
         <p:nvSpPr>
@@ -24848,7 +25325,7 @@
           <a:p>
             <a:fld id="{4438A2D4-3867-488E-A04E-7BFFCAED45A6}" type="slidenum">
               <a:rPr lang="ko-KR" altLang="en-US" smtClean="0"/>
-              <a:t>‹#›</a:t>
+              <a:t>4</a:t>
             </a:fld>
             <a:endParaRPr lang="ko-KR" altLang="en-US" dirty="0"/>
           </a:p>
@@ -24860,7 +25337,13 @@
           <p:cNvGraphicFramePr>
             <a:graphicFrameLocks noGrp="1"/>
           </p:cNvGraphicFramePr>
-          <p:nvPr/>
+          <p:nvPr>
+            <p:extLst>
+              <p:ext uri="{D42A27DB-BD31-4B8C-83A1-F6EECF244321}">
+                <p14:modId xmlns:p14="http://schemas.microsoft.com/office/powerpoint/2010/main" val="1636922198"/>
+              </p:ext>
+            </p:extLst>
+          </p:nvPr>
         </p:nvGraphicFramePr>
         <p:xfrm>
           <a:off x="838200" y="3900000"/>
@@ -24873,11 +25356,41 @@
                 <a:tableStyleId>{5A111915-BE36-4E01-A7E5-04B1672EAD32}</a:tableStyleId>
               </a:tblPr>
               <a:tblGrid>
-                <a:gridCol w="2103120"/>
-                <a:gridCol w="2103120"/>
-                <a:gridCol w="2103120"/>
-                <a:gridCol w="2103120"/>
-                <a:gridCol w="2103120"/>
+                <a:gridCol w="2103120">
+                  <a:extLst>
+                    <a:ext uri="{9D8B030D-6E8A-4147-A177-3AD203B41FA5}">
+                      <a16:colId xmlns:a16="http://schemas.microsoft.com/office/drawing/2014/main" val="20000"/>
+                    </a:ext>
+                  </a:extLst>
+                </a:gridCol>
+                <a:gridCol w="2103120">
+                  <a:extLst>
+                    <a:ext uri="{9D8B030D-6E8A-4147-A177-3AD203B41FA5}">
+                      <a16:colId xmlns:a16="http://schemas.microsoft.com/office/drawing/2014/main" val="20001"/>
+                    </a:ext>
+                  </a:extLst>
+                </a:gridCol>
+                <a:gridCol w="2103120">
+                  <a:extLst>
+                    <a:ext uri="{9D8B030D-6E8A-4147-A177-3AD203B41FA5}">
+                      <a16:colId xmlns:a16="http://schemas.microsoft.com/office/drawing/2014/main" val="20002"/>
+                    </a:ext>
+                  </a:extLst>
+                </a:gridCol>
+                <a:gridCol w="2103120">
+                  <a:extLst>
+                    <a:ext uri="{9D8B030D-6E8A-4147-A177-3AD203B41FA5}">
+                      <a16:colId xmlns:a16="http://schemas.microsoft.com/office/drawing/2014/main" val="20003"/>
+                    </a:ext>
+                  </a:extLst>
+                </a:gridCol>
+                <a:gridCol w="2103120">
+                  <a:extLst>
+                    <a:ext uri="{9D8B030D-6E8A-4147-A177-3AD203B41FA5}">
+                      <a16:colId xmlns:a16="http://schemas.microsoft.com/office/drawing/2014/main" val="20004"/>
+                    </a:ext>
+                  </a:extLst>
+                </a:gridCol>
               </a:tblGrid>
               <a:tr h="466666">
                 <a:tc>
@@ -24887,7 +25400,7 @@
                     <a:p>
                       <a:pPr algn="ctr"/>
                       <a:r>
-                        <a:rPr sz="1800" b="1"/>
+                        <a:rPr sz="1800" b="1" dirty="0"/>
                         <a:t>r</a:t>
                       </a:r>
                     </a:p>
@@ -24938,7 +25451,7 @@
                     <a:p>
                       <a:pPr algn="ctr"/>
                       <a:r>
-                        <a:rPr sz="1800" b="1"/>
+                        <a:rPr sz="1800" b="1" dirty="0"/>
                         <a:t>HighBits(r)</a:t>
                       </a:r>
                     </a:p>
@@ -24989,7 +25502,7 @@
                     <a:p>
                       <a:pPr algn="ctr"/>
                       <a:r>
-                        <a:rPr sz="1800" b="1"/>
+                        <a:rPr sz="1800" b="1" dirty="0"/>
                         <a:t>r+2의 HighBits</a:t>
                       </a:r>
                     </a:p>
@@ -25040,7 +25553,7 @@
                     <a:p>
                       <a:pPr algn="ctr"/>
                       <a:r>
-                        <a:rPr sz="1800" b="1"/>
+                        <a:rPr sz="1800" b="1" dirty="0"/>
                         <a:t>r−2의 HighBits</a:t>
                       </a:r>
                     </a:p>
@@ -25091,7 +25604,7 @@
                     <a:p>
                       <a:pPr algn="ctr"/>
                       <a:r>
-                        <a:rPr sz="1800" b="1"/>
+                        <a:rPr sz="1800" b="1" dirty="0"/>
                         <a:t>판정</a:t>
                       </a:r>
                     </a:p>
@@ -25135,6 +25648,11 @@
                     </a:lnB>
                   </a:tcPr>
                 </a:tc>
+                <a:extLst>
+                  <a:ext uri="{0D108BD9-81ED-4DB2-BD59-A6C34878D82A}">
+                    <a16:rowId xmlns:a16="http://schemas.microsoft.com/office/drawing/2014/main" val="10000"/>
+                  </a:ext>
+                </a:extLst>
               </a:tr>
               <a:tr h="466666">
                 <a:tc>
@@ -25144,7 +25662,7 @@
                     <a:p>
                       <a:pPr algn="ctr"/>
                       <a:r>
-                        <a:rPr sz="1800"/>
+                        <a:rPr sz="1800" dirty="0"/>
                         <a:t>6</a:t>
                       </a:r>
                     </a:p>
@@ -25195,7 +25713,7 @@
                     <a:p>
                       <a:pPr algn="ctr"/>
                       <a:r>
-                        <a:rPr sz="1800"/>
+                        <a:rPr sz="1800" dirty="0"/>
                         <a:t>1</a:t>
                       </a:r>
                     </a:p>
@@ -25246,7 +25764,7 @@
                     <a:p>
                       <a:pPr algn="ctr"/>
                       <a:r>
-                        <a:rPr sz="1800"/>
+                        <a:rPr sz="1800" dirty="0"/>
                         <a:t>8 → 2 (바뀜)</a:t>
                       </a:r>
                     </a:p>
@@ -25297,7 +25815,7 @@
                     <a:p>
                       <a:pPr algn="ctr"/>
                       <a:r>
-                        <a:rPr sz="1800"/>
+                        <a:rPr sz="1800" dirty="0"/>
                         <a:t>4 → 1 (안 바뀜)</a:t>
                       </a:r>
                     </a:p>
@@ -25348,7 +25866,7 @@
                     <a:p>
                       <a:pPr algn="ctr"/>
                       <a:r>
-                        <a:rPr sz="1800"/>
+                        <a:rPr sz="1800" dirty="0"/>
                         <a:t>정상: 하나만 바뀜</a:t>
                       </a:r>
                     </a:p>
@@ -25392,6 +25910,11 @@
                     </a:lnB>
                   </a:tcPr>
                 </a:tc>
+                <a:extLst>
+                  <a:ext uri="{0D108BD9-81ED-4DB2-BD59-A6C34878D82A}">
+                    <a16:rowId xmlns:a16="http://schemas.microsoft.com/office/drawing/2014/main" val="10001"/>
+                  </a:ext>
+                </a:extLst>
               </a:tr>
               <a:tr h="466668">
                 <a:tc>
@@ -25401,7 +25924,7 @@
                     <a:p>
                       <a:pPr algn="ctr"/>
                       <a:r>
-                        <a:rPr sz="1800"/>
+                        <a:rPr sz="1800" dirty="0"/>
                         <a:t>20</a:t>
                       </a:r>
                     </a:p>
@@ -25452,7 +25975,7 @@
                     <a:p>
                       <a:pPr algn="ctr"/>
                       <a:r>
-                        <a:rPr sz="1800"/>
+                        <a:rPr sz="1800" dirty="0"/>
                         <a:t>5</a:t>
                       </a:r>
                     </a:p>
@@ -25503,7 +26026,7 @@
                     <a:p>
                       <a:pPr algn="ctr"/>
                       <a:r>
-                        <a:rPr sz="1800"/>
+                        <a:rPr sz="1800" dirty="0"/>
                         <a:t>22≡1 → 0 (바뀜)</a:t>
                       </a:r>
                     </a:p>
@@ -25554,7 +26077,7 @@
                     <a:p>
                       <a:pPr algn="ctr"/>
                       <a:r>
-                        <a:rPr sz="1800"/>
+                        <a:rPr sz="1800" dirty="0"/>
                         <a:t>18 → 4 (바뀜)</a:t>
                       </a:r>
                     </a:p>
@@ -25605,7 +26128,7 @@
                     <a:p>
                       <a:pPr algn="ctr"/>
                       <a:r>
-                        <a:rPr sz="1800"/>
+                        <a:rPr sz="1800" dirty="0"/>
                         <a:t>문제: 둘 다 바뀜</a:t>
                       </a:r>
                     </a:p>
@@ -25649,6 +26172,11 @@
                     </a:lnB>
                   </a:tcPr>
                 </a:tc>
+                <a:extLst>
+                  <a:ext uri="{0D108BD9-81ED-4DB2-BD59-A6C34878D82A}">
+                    <a16:rowId xmlns:a16="http://schemas.microsoft.com/office/drawing/2014/main" val="10002"/>
+                  </a:ext>
+                </a:extLst>
               </a:tr>
             </a:tbl>
           </a:graphicData>
@@ -25663,7 +26191,7 @@
 </file>
 
 <file path=ppt/slides/slide5.xml><?xml version="1.0" encoding="utf-8"?>
-<p:sld xmlns:a="http://schemas.openxmlformats.org/drawingml/2006/main" xmlns:p="http://schemas.openxmlformats.org/presentationml/2006/main" xmlns:r="http://schemas.openxmlformats.org/officeDocument/2006/relationships">
+<p:sld xmlns:a="http://schemas.openxmlformats.org/drawingml/2006/main" xmlns:r="http://schemas.openxmlformats.org/officeDocument/2006/relationships" xmlns:p="http://schemas.openxmlformats.org/presentationml/2006/main">
   <p:cSld>
     <p:spTree>
       <p:nvGrpSpPr>
@@ -25671,7 +26199,14 @@
         <p:cNvGrpSpPr/>
         <p:nvPr/>
       </p:nvGrpSpPr>
-      <p:grpSpPr/>
+      <p:grpSpPr>
+        <a:xfrm>
+          <a:off x="0" y="0"/>
+          <a:ext cx="0" cy="0"/>
+          <a:chOff x="0" y="0"/>
+          <a:chExt cx="0" cy="0"/>
+        </a:xfrm>
+      </p:grpSpPr>
       <p:sp>
         <p:nvSpPr>
           <p:cNvPr id="2" name="Title 1"/>
@@ -25693,6 +26228,7 @@
           <a:lstStyle/>
           <a:p>
             <a:r>
+              <a:rPr dirty="0"/>
               <a:t>경계 수정이 전제를 회복시킨다</a:t>
             </a:r>
           </a:p>
@@ -25717,28 +26253,43 @@
               </a:xfrm>
             </p:spPr>
             <p:txBody>
-              <a:bodyPr wrap="square"/>
+              <a:bodyPr wrap="square">
+                <a:normAutofit lnSpcReduction="10000"/>
+              </a:bodyPr>
               <a:lstStyle/>
               <a:p>
-                <a:pPr/>
                 <a:r>
+                  <a:rPr dirty="0"/>
                   <a:t>수정: </a:t>
                 </a:r>
-                <a14:m xmlns:m="http://schemas.openxmlformats.org/officeDocument/2006/math">
-                  <m:oMath xmlns:mml="http://www.w3.org/1998/Math/MathML">
+                <a14:m>
+                  <m:oMath xmlns:m="http://schemas.openxmlformats.org/officeDocument/2006/math">
                     <m:r>
                       <a:rPr lang="en-US" i="1">
                         <a:latin typeface="Cambria Math"/>
                       </a:rPr>
-                      <m:t>r−</m:t>
+                      <m:t>𝑟</m:t>
+                    </m:r>
+                    <m:r>
+                      <a:rPr lang="en-US" i="1">
+                        <a:latin typeface="Cambria Math"/>
+                      </a:rPr>
+                      <m:t>−</m:t>
                     </m:r>
                     <m:sSub>
+                      <m:sSubPr>
+                        <m:ctrlPr>
+                          <a:rPr lang="en-US" i="1">
+                            <a:latin typeface="Cambria Math" panose="02040503050406030204" pitchFamily="18" charset="0"/>
+                          </a:rPr>
+                        </m:ctrlPr>
+                      </m:sSubPr>
                       <m:e>
                         <m:r>
                           <a:rPr lang="en-US" i="1">
                             <a:latin typeface="Cambria Math"/>
                           </a:rPr>
-                          <m:t>r</m:t>
+                          <m:t>𝑟</m:t>
                         </m:r>
                       </m:e>
                       <m:sub>
@@ -25754,22 +26305,42 @@
                       <a:rPr lang="en-US" i="1">
                         <a:latin typeface="Cambria Math"/>
                       </a:rPr>
-                      <m:t>=q−1</m:t>
+                      <m:t>=</m:t>
+                    </m:r>
+                    <m:r>
+                      <a:rPr lang="en-US" i="1">
+                        <a:latin typeface="Cambria Math"/>
+                      </a:rPr>
+                      <m:t>𝑞</m:t>
+                    </m:r>
+                    <m:r>
+                      <a:rPr lang="en-US" i="1">
+                        <a:latin typeface="Cambria Math"/>
+                      </a:rPr>
+                      <m:t>−1</m:t>
                     </m:r>
                   </m:oMath>
                 </a14:m>
                 <a:r>
+                  <a:rPr dirty="0"/>
                   <a:t>인 경우에만 </a:t>
                 </a:r>
-                <a14:m xmlns:m="http://schemas.openxmlformats.org/officeDocument/2006/math">
-                  <m:oMath xmlns:mml="http://www.w3.org/1998/Math/MathML">
+                <a14:m>
+                  <m:oMath xmlns:m="http://schemas.openxmlformats.org/officeDocument/2006/math">
                     <m:sSub>
+                      <m:sSubPr>
+                        <m:ctrlPr>
+                          <a:rPr lang="en-US">
+                            <a:latin typeface="Cambria Math" panose="02040503050406030204" pitchFamily="18" charset="0"/>
+                          </a:rPr>
+                        </m:ctrlPr>
+                      </m:sSubPr>
                       <m:e>
                         <m:r>
                           <a:rPr lang="en-US" i="1">
                             <a:latin typeface="Cambria Math"/>
                           </a:rPr>
-                          <m:t>r</m:t>
+                          <m:t>𝑟</m:t>
                         </m:r>
                       </m:e>
                       <m:sub>
@@ -25788,21 +26359,28 @@
                       <m:t>=0,</m:t>
                     </m:r>
                     <m:r>
+                      <m:rPr>
+                        <m:nor/>
+                      </m:rPr>
                       <a:rPr lang="en-US" i="0">
                         <a:latin typeface="Cambria Math"/>
                       </a:rPr>
-                      <m:rPr>
-                        <m:nor/>
-                      </m:rPr>
-                      <m:t> </m:t>
+                      <m:t> </m:t>
                     </m:r>
                     <m:sSub>
+                      <m:sSubPr>
+                        <m:ctrlPr>
+                          <a:rPr lang="en-US" i="1">
+                            <a:latin typeface="Cambria Math" panose="02040503050406030204" pitchFamily="18" charset="0"/>
+                          </a:rPr>
+                        </m:ctrlPr>
+                      </m:sSubPr>
                       <m:e>
                         <m:r>
                           <a:rPr lang="en-US" i="1">
                             <a:latin typeface="Cambria Math"/>
                           </a:rPr>
-                          <m:t>r</m:t>
+                          <m:t>𝑟</m:t>
                         </m:r>
                       </m:e>
                       <m:sub>
@@ -25821,12 +26399,19 @@
                       <m:t>=</m:t>
                     </m:r>
                     <m:sSub>
+                      <m:sSubPr>
+                        <m:ctrlPr>
+                          <a:rPr lang="en-US" i="1">
+                            <a:latin typeface="Cambria Math" panose="02040503050406030204" pitchFamily="18" charset="0"/>
+                          </a:rPr>
+                        </m:ctrlPr>
+                      </m:sSubPr>
                       <m:e>
                         <m:r>
                           <a:rPr lang="en-US" i="1">
                             <a:latin typeface="Cambria Math"/>
                           </a:rPr>
-                          <m:t>r</m:t>
+                          <m:t>𝑟</m:t>
                         </m:r>
                       </m:e>
                       <m:sub>
@@ -25847,16 +26432,17 @@
                   </m:oMath>
                 </a14:m>
                 <a:r>
+                  <a:rPr dirty="0"/>
                   <a:t> (그 외는 그대로)</a:t>
                 </a:r>
               </a:p>
               <a:p>
-                <a:pPr/>
                 <a:r>
+                  <a:rPr dirty="0"/>
                   <a:t>r = 19, 20의 </a:t>
                 </a:r>
-                <a14:m xmlns:m="http://schemas.openxmlformats.org/officeDocument/2006/math">
-                  <m:oMath xmlns:mml="http://www.w3.org/1998/Math/MathML">
+                <a14:m>
+                  <m:oMath xmlns:m="http://schemas.openxmlformats.org/officeDocument/2006/math">
                     <m:r>
                       <a:rPr lang="en-US" i="1">
                         <a:latin typeface="Cambria Math"/>
@@ -25864,12 +26450,12 @@
                       <m:t>(</m:t>
                     </m:r>
                     <m:r>
+                      <m:rPr>
+                        <m:sty m:val="p"/>
+                      </m:rPr>
                       <a:rPr lang="en-US" i="0">
                         <a:latin typeface="Cambria Math"/>
                       </a:rPr>
-                      <m:rPr>
-                        <m:sty m:val="p"/>
-                      </m:rPr>
                       <m:t>HighBits</m:t>
                     </m:r>
                     <m:r>
@@ -25879,12 +26465,12 @@
                       <m:t>,</m:t>
                     </m:r>
                     <m:r>
+                      <m:rPr>
+                        <m:sty m:val="p"/>
+                      </m:rPr>
                       <a:rPr lang="en-US" i="0">
                         <a:latin typeface="Cambria Math"/>
                       </a:rPr>
-                      <m:rPr>
-                        <m:sty m:val="p"/>
-                      </m:rPr>
                       <m:t>LowBits</m:t>
                     </m:r>
                     <m:r>
@@ -25896,23 +26482,24 @@
                   </m:oMath>
                 </a14:m>
                 <a:r>
+                  <a:rPr dirty="0"/>
                   <a:t>가 (5, −1), (5, 0) → (0, −2), (0, −1)로 바뀐다 (다른 r은 그대로)</a:t>
                 </a:r>
               </a:p>
               <a:p>
-                <a:pPr/>
                 <a:r>
+                  <a:rPr dirty="0"/>
                   <a:t>재검증: </a:t>
                 </a:r>
-                <a14:m xmlns:m="http://schemas.openxmlformats.org/officeDocument/2006/math">
-                  <m:oMath xmlns:mml="http://www.w3.org/1998/Math/MathML">
+                <a14:m>
+                  <m:oMath xmlns:m="http://schemas.openxmlformats.org/officeDocument/2006/math">
                     <m:r>
+                      <m:rPr>
+                        <m:sty m:val="p"/>
+                      </m:rPr>
                       <a:rPr lang="en-US" i="0">
                         <a:latin typeface="Cambria Math"/>
                       </a:rPr>
-                      <m:rPr>
-                        <m:sty m:val="p"/>
-                      </m:rPr>
                       <m:t>HighBits</m:t>
                     </m:r>
                     <m:r>
@@ -25924,23 +26511,24 @@
                   </m:oMath>
                 </a14:m>
                 <a:r>
+                  <a:rPr dirty="0"/>
                   <a:t>에 +2 → 0 (안 바뀜), −2 → 4 (바뀜) — 한 방향만 남는다</a:t>
                 </a:r>
               </a:p>
               <a:p>
-                <a:pPr/>
                 <a:r>
+                  <a:rPr dirty="0"/>
                   <a:t>따라서 </a:t>
                 </a:r>
-                <a14:m xmlns:m="http://schemas.openxmlformats.org/officeDocument/2006/math">
-                  <m:oMath xmlns:mml="http://www.w3.org/1998/Math/MathML">
+                <a14:m>
+                  <m:oMath xmlns:m="http://schemas.openxmlformats.org/officeDocument/2006/math">
                     <m:r>
+                      <m:rPr>
+                        <m:sty m:val="p"/>
+                      </m:rPr>
                       <a:rPr lang="en-US" i="0">
                         <a:latin typeface="Cambria Math"/>
                       </a:rPr>
-                      <m:rPr>
-                        <m:sty m:val="p"/>
-                      </m:rPr>
                       <m:t>UseHint</m:t>
                     </m:r>
                     <m:r>
@@ -25950,44 +26538,178 @@
                       <m:t>(</m:t>
                     </m:r>
                     <m:r>
+                      <m:rPr>
+                        <m:sty m:val="p"/>
+                      </m:rPr>
                       <a:rPr lang="en-US" i="0">
                         <a:latin typeface="Cambria Math"/>
                       </a:rPr>
-                      <m:rPr>
-                        <m:sty m:val="p"/>
-                      </m:rPr>
                       <m:t>MakeHint</m:t>
                     </m:r>
                     <m:r>
                       <a:rPr lang="en-US" i="1">
                         <a:latin typeface="Cambria Math"/>
                       </a:rPr>
-                      <m:t>(z,r,α),r,α)=</m:t>
+                      <m:t>(</m:t>
                     </m:r>
                     <m:r>
+                      <a:rPr lang="en-US" i="1">
+                        <a:latin typeface="Cambria Math"/>
+                      </a:rPr>
+                      <m:t>𝑧</m:t>
+                    </m:r>
+                    <m:r>
+                      <a:rPr lang="en-US" i="1">
+                        <a:latin typeface="Cambria Math"/>
+                      </a:rPr>
+                      <m:t>,</m:t>
+                    </m:r>
+                    <m:r>
+                      <a:rPr lang="en-US" i="1">
+                        <a:latin typeface="Cambria Math"/>
+                      </a:rPr>
+                      <m:t>𝑟</m:t>
+                    </m:r>
+                    <m:r>
+                      <a:rPr lang="en-US" i="1">
+                        <a:latin typeface="Cambria Math"/>
+                      </a:rPr>
+                      <m:t>,</m:t>
+                    </m:r>
+                    <m:r>
+                      <a:rPr lang="en-US" i="1">
+                        <a:latin typeface="Cambria Math"/>
+                      </a:rPr>
+                      <m:t>𝛼</m:t>
+                    </m:r>
+                    <m:r>
+                      <a:rPr lang="en-US" i="1">
+                        <a:latin typeface="Cambria Math"/>
+                      </a:rPr>
+                      <m:t>),</m:t>
+                    </m:r>
+                    <m:r>
+                      <a:rPr lang="en-US" i="1">
+                        <a:latin typeface="Cambria Math"/>
+                      </a:rPr>
+                      <m:t>𝑟</m:t>
+                    </m:r>
+                    <m:r>
+                      <a:rPr lang="en-US" i="1">
+                        <a:latin typeface="Cambria Math"/>
+                      </a:rPr>
+                      <m:t>,</m:t>
+                    </m:r>
+                    <m:r>
+                      <a:rPr lang="en-US" i="1">
+                        <a:latin typeface="Cambria Math"/>
+                      </a:rPr>
+                      <m:t>𝛼</m:t>
+                    </m:r>
+                    <m:r>
+                      <a:rPr lang="en-US" i="1">
+                        <a:latin typeface="Cambria Math"/>
+                      </a:rPr>
+                      <m:t>)=</m:t>
+                    </m:r>
+                    <m:r>
+                      <m:rPr>
+                        <m:sty m:val="p"/>
+                      </m:rPr>
                       <a:rPr lang="en-US" i="0">
                         <a:latin typeface="Cambria Math"/>
                       </a:rPr>
-                      <m:rPr>
-                        <m:sty m:val="p"/>
-                      </m:rPr>
                       <m:t>HighBits</m:t>
                     </m:r>
                     <m:r>
                       <a:rPr lang="en-US" i="1">
                         <a:latin typeface="Cambria Math"/>
                       </a:rPr>
-                      <m:t>(r+z,α)</m:t>
+                      <m:t>(</m:t>
+                    </m:r>
+                    <m:r>
+                      <a:rPr lang="en-US" i="1">
+                        <a:latin typeface="Cambria Math"/>
+                      </a:rPr>
+                      <m:t>𝑟</m:t>
+                    </m:r>
+                    <m:r>
+                      <a:rPr lang="en-US" i="1">
+                        <a:latin typeface="Cambria Math"/>
+                      </a:rPr>
+                      <m:t>+</m:t>
+                    </m:r>
+                    <m:r>
+                      <a:rPr lang="en-US" i="1">
+                        <a:latin typeface="Cambria Math"/>
+                      </a:rPr>
+                      <m:t>𝑧</m:t>
+                    </m:r>
+                    <m:r>
+                      <a:rPr lang="en-US" i="1">
+                        <a:latin typeface="Cambria Math"/>
+                      </a:rPr>
+                      <m:t>,</m:t>
+                    </m:r>
+                    <m:r>
+                      <a:rPr lang="en-US" i="1">
+                        <a:latin typeface="Cambria Math"/>
+                      </a:rPr>
+                      <m:t>𝛼</m:t>
+                    </m:r>
+                    <m:r>
+                      <a:rPr lang="en-US" i="1">
+                        <a:latin typeface="Cambria Math"/>
+                      </a:rPr>
+                      <m:t>)</m:t>
                     </m:r>
                   </m:oMath>
                 </a14:m>
                 <a:r>
+                  <a:rPr dirty="0"/>
                   <a:t>가 예외 없이 성립한다</a:t>
                 </a:r>
               </a:p>
             </p:txBody>
           </p:sp>
         </mc:Choice>
+        <mc:Fallback>
+          <p:sp>
+            <p:nvSpPr>
+              <p:cNvPr id="3" name="Content Placeholder 2"/>
+              <p:cNvSpPr>
+                <a:spLocks noGrp="1" noRot="1" noChangeAspect="1" noMove="1" noResize="1" noEditPoints="1" noAdjustHandles="1" noChangeArrowheads="1" noChangeShapeType="1" noTextEdit="1"/>
+              </p:cNvSpPr>
+              <p:nvPr>
+                <p:ph idx="1"/>
+              </p:nvPr>
+            </p:nvSpPr>
+            <p:spPr>
+              <a:xfrm>
+                <a:off x="838200" y="1295322"/>
+                <a:ext cx="10515600" cy="2000000"/>
+              </a:xfrm>
+              <a:blipFill>
+                <a:blip r:embed="rId2"/>
+                <a:stretch>
+                  <a:fillRect l="-406" b="-2736"/>
+                </a:stretch>
+              </a:blipFill>
+            </p:spPr>
+            <p:txBody>
+              <a:bodyPr/>
+              <a:lstStyle/>
+              <a:p>
+                <a:r>
+                  <a:rPr lang="ko-KR" altLang="en-US">
+                    <a:noFill/>
+                  </a:rPr>
+                  <a:t> </a:t>
+                </a:r>
+              </a:p>
+            </p:txBody>
+          </p:sp>
+        </mc:Fallback>
       </mc:AlternateContent>
       <p:sp>
         <p:nvSpPr>
@@ -26012,7 +26734,7 @@
           <a:p>
             <a:fld id="{4438A2D4-3867-488E-A04E-7BFFCAED45A6}" type="slidenum">
               <a:rPr lang="ko-KR" altLang="en-US" smtClean="0"/>
-              <a:t>‹#›</a:t>
+              <a:t>5</a:t>
             </a:fld>
             <a:endParaRPr lang="ko-KR" altLang="en-US" dirty="0"/>
           </a:p>
@@ -26027,7 +26749,7 @@
           <p:nvPr/>
         </p:nvPicPr>
         <p:blipFill>
-          <a:blip r:embed="rId2"/>
+          <a:blip r:embed="rId3"/>
           <a:stretch>
             <a:fillRect/>
           </a:stretch>
@@ -26051,7 +26773,7 @@
           <p:nvPr/>
         </p:nvPicPr>
         <p:blipFill>
-          <a:blip r:embed="rId3"/>
+          <a:blip r:embed="rId4"/>
           <a:stretch>
             <a:fillRect/>
           </a:stretch>
@@ -26599,7 +27321,7 @@
           <a:p>
             <a:fld id="{4438A2D4-3867-488E-A04E-7BFFCAED45A6}" type="slidenum">
               <a:rPr lang="ko-KR" altLang="en-US" smtClean="0"/>
-              <a:t>3</a:t>
+              <a:t>6</a:t>
             </a:fld>
             <a:endParaRPr lang="ko-KR" altLang="en-US" dirty="0"/>
           </a:p>
@@ -27022,7 +27744,7 @@
           <a:p>
             <a:fld id="{4438A2D4-3867-488E-A04E-7BFFCAED45A6}" type="slidenum">
               <a:rPr lang="ko-KR" altLang="en-US" smtClean="0"/>
-              <a:t>4</a:t>
+              <a:t>7</a:t>
             </a:fld>
             <a:endParaRPr lang="ko-KR" altLang="en-US" dirty="0"/>
           </a:p>
@@ -28071,7 +28793,7 @@
           <a:p>
             <a:fld id="{4438A2D4-3867-488E-A04E-7BFFCAED45A6}" type="slidenum">
               <a:rPr lang="ko-KR" altLang="en-US" smtClean="0"/>
-              <a:t>5</a:t>
+              <a:t>8</a:t>
             </a:fld>
             <a:endParaRPr lang="ko-KR" altLang="en-US" dirty="0"/>
           </a:p>
@@ -29498,7 +30220,7 @@
           <a:p>
             <a:fld id="{4438A2D4-3867-488E-A04E-7BFFCAED45A6}" type="slidenum">
               <a:rPr lang="ko-KR" altLang="en-US" smtClean="0"/>
-              <a:t>6</a:t>
+              <a:t>9</a:t>
             </a:fld>
             <a:endParaRPr lang="ko-KR" altLang="en-US" dirty="0"/>
           </a:p>

</xml_diff>

<commit_message>
add: last update presentation/0828_13_Number-Theoretic-Transform.pptx
</commit_message>
<xml_diff>
--- a/presentation/0828_13_Number-Theoretic-Transform.pptx
+++ b/presentation/0828_13_Number-Theoretic-Transform.pptx
@@ -792,6 +792,94 @@
     <p:extLst>
       <p:ext uri="{BB962C8B-B14F-4D97-AF65-F5344CB8AC3E}">
         <p14:creationId xmlns:p14="http://schemas.microsoft.com/office/powerpoint/2010/main" val="1712491916"/>
+      </p:ext>
+    </p:extLst>
+  </p:cSld>
+  <p:clrMapOvr>
+    <a:masterClrMapping/>
+  </p:clrMapOvr>
+</p:notes>
+</file>
+
+<file path=ppt/notesSlides/notesSlide4.xml><?xml version="1.0" encoding="utf-8"?>
+<p:notes xmlns:a="http://schemas.openxmlformats.org/drawingml/2006/main" xmlns:r="http://schemas.openxmlformats.org/officeDocument/2006/relationships" xmlns:p="http://schemas.openxmlformats.org/presentationml/2006/main">
+  <p:cSld>
+    <p:spTree>
+      <p:nvGrpSpPr>
+        <p:cNvPr id="1" name=""/>
+        <p:cNvGrpSpPr/>
+        <p:nvPr/>
+      </p:nvGrpSpPr>
+      <p:grpSpPr>
+        <a:xfrm>
+          <a:off x="0" y="0"/>
+          <a:ext cx="0" cy="0"/>
+          <a:chOff x="0" y="0"/>
+          <a:chExt cx="0" cy="0"/>
+        </a:xfrm>
+      </p:grpSpPr>
+      <p:sp>
+        <p:nvSpPr>
+          <p:cNvPr id="2" name="슬라이드 이미지 개체 틀 1"/>
+          <p:cNvSpPr>
+            <a:spLocks noGrp="1" noRot="1" noChangeAspect="1"/>
+          </p:cNvSpPr>
+          <p:nvPr>
+            <p:ph type="sldImg"/>
+          </p:nvPr>
+        </p:nvSpPr>
+        <p:spPr/>
+      </p:sp>
+      <p:sp>
+        <p:nvSpPr>
+          <p:cNvPr id="3" name="슬라이드 노트 개체 틀 2"/>
+          <p:cNvSpPr>
+            <a:spLocks noGrp="1"/>
+          </p:cNvSpPr>
+          <p:nvPr>
+            <p:ph type="body" idx="1"/>
+          </p:nvPr>
+        </p:nvSpPr>
+        <p:spPr/>
+        <p:txBody>
+          <a:bodyPr/>
+          <a:lstStyle/>
+          <a:p>
+            <a:r>
+              <a:rPr lang="ko-KR" altLang="en-US" dirty="0" err="1"/>
+              <a:t>물어보실듯</a:t>
+            </a:r>
+            <a:endParaRPr lang="ko-KR" altLang="en-US" dirty="0"/>
+          </a:p>
+        </p:txBody>
+      </p:sp>
+      <p:sp>
+        <p:nvSpPr>
+          <p:cNvPr id="4" name="슬라이드 번호 개체 틀 3"/>
+          <p:cNvSpPr>
+            <a:spLocks noGrp="1"/>
+          </p:cNvSpPr>
+          <p:nvPr>
+            <p:ph type="sldNum" sz="quarter" idx="5"/>
+          </p:nvPr>
+        </p:nvSpPr>
+        <p:spPr/>
+        <p:txBody>
+          <a:bodyPr/>
+          <a:lstStyle/>
+          <a:p>
+            <a:fld id="{513BC5EA-D886-4875-B891-B25A6CC49088}" type="slidenum">
+              <a:rPr lang="ko-KR" altLang="en-US" smtClean="0"/>
+              <a:t>10</a:t>
+            </a:fld>
+            <a:endParaRPr lang="ko-KR" altLang="en-US" dirty="0"/>
+          </a:p>
+        </p:txBody>
+      </p:sp>
+    </p:spTree>
+    <p:extLst>
+      <p:ext uri="{BB962C8B-B14F-4D97-AF65-F5344CB8AC3E}">
+        <p14:creationId xmlns:p14="http://schemas.microsoft.com/office/powerpoint/2010/main" val="2997106907"/>
       </p:ext>
     </p:extLst>
   </p:cSld>
@@ -4850,7 +4938,7 @@
                 <a:ext cx="10515600" cy="4701089"/>
               </a:xfrm>
               <a:blipFill>
-                <a:blip r:embed="rId2"/>
+                <a:blip r:embed="rId3"/>
                 <a:stretch>
                   <a:fillRect l="-406"/>
                 </a:stretch>
@@ -6246,8 +6334,8 @@
           </a:p>
         </p:txBody>
       </p:sp>
-      <mc:AlternateContent xmlns:mc="http://schemas.openxmlformats.org/markup-compatibility/2006">
-        <mc:Choice xmlns:a14="http://schemas.microsoft.com/office/drawing/2010/main" Requires="a14">
+      <mc:AlternateContent xmlns:mc="http://schemas.openxmlformats.org/markup-compatibility/2006" xmlns:a14="http://schemas.microsoft.com/office/drawing/2010/main">
+        <mc:Choice Requires="a14">
           <p:sp>
             <p:nvSpPr>
               <p:cNvPr id="3" name="Content Placeholder 2"/>
@@ -6416,7 +6504,7 @@
                     <m:sSubSup>
                       <m:sSubSupPr>
                         <m:ctrlPr>
-                          <a:rPr lang="en-US">
+                          <a:rPr lang="en-US" i="1">
                             <a:latin typeface="Cambria Math" panose="02040503050406030204" pitchFamily="18" charset="0"/>
                           </a:rPr>
                         </m:ctrlPr>
@@ -6457,7 +6545,7 @@
                     <m:sSup>
                       <m:sSupPr>
                         <m:ctrlPr>
-                          <a:rPr lang="en-US">
+                          <a:rPr lang="en-US" i="1">
                             <a:latin typeface="Cambria Math" panose="02040503050406030204" pitchFamily="18" charset="0"/>
                           </a:rPr>
                         </m:ctrlPr>
@@ -6496,7 +6584,7 @@
                     <m:sSub>
                       <m:sSubPr>
                         <m:ctrlPr>
-                          <a:rPr lang="en-US">
+                          <a:rPr lang="en-US" i="1">
                             <a:latin typeface="Cambria Math" panose="02040503050406030204" pitchFamily="18" charset="0"/>
                           </a:rPr>
                         </m:ctrlPr>
@@ -6796,7 +6884,7 @@
                       <m:sSup>
                         <m:sSupPr>
                           <m:ctrlPr>
-                            <a:rPr lang="en-US">
+                            <a:rPr lang="en-US" i="1">
                               <a:latin typeface="Cambria Math" panose="02040503050406030204" pitchFamily="18" charset="0"/>
                             </a:rPr>
                           </m:ctrlPr>
@@ -7757,7 +7845,7 @@
             </p:txBody>
           </p:sp>
         </mc:Choice>
-        <mc:Fallback>
+        <mc:Fallback xmlns="">
           <p:sp>
             <p:nvSpPr>
               <p:cNvPr id="3" name="Content Placeholder 2"/>
@@ -8067,8 +8155,8 @@
           </a:p>
         </p:txBody>
       </p:sp>
-      <mc:AlternateContent xmlns:mc="http://schemas.openxmlformats.org/markup-compatibility/2006">
-        <mc:Choice xmlns:a14="http://schemas.microsoft.com/office/drawing/2010/main" Requires="a14">
+      <mc:AlternateContent xmlns:mc="http://schemas.openxmlformats.org/markup-compatibility/2006" xmlns:a14="http://schemas.microsoft.com/office/drawing/2010/main">
+        <mc:Choice Requires="a14">
           <p:sp>
             <p:nvSpPr>
               <p:cNvPr id="3" name="Content Placeholder 2"/>
@@ -8098,7 +8186,7 @@
                     <m:sSub>
                       <m:sSubPr>
                         <m:ctrlPr>
-                          <a:rPr lang="en-US">
+                          <a:rPr lang="en-US" i="1">
                             <a:latin typeface="Cambria Math" panose="02040503050406030204" pitchFamily="18" charset="0"/>
                           </a:rPr>
                         </m:ctrlPr>
@@ -8373,7 +8461,7 @@
                     <m:sSub>
                       <m:sSubPr>
                         <m:ctrlPr>
-                          <a:rPr lang="en-US">
+                          <a:rPr lang="en-US" i="1">
                             <a:latin typeface="Cambria Math" panose="02040503050406030204" pitchFamily="18" charset="0"/>
                           </a:rPr>
                         </m:ctrlPr>
@@ -8406,7 +8494,7 @@
                     <m:sSup>
                       <m:sSupPr>
                         <m:ctrlPr>
-                          <a:rPr lang="en-US">
+                          <a:rPr lang="en-US" i="1">
                             <a:latin typeface="Cambria Math" panose="02040503050406030204" pitchFamily="18" charset="0"/>
                           </a:rPr>
                         </m:ctrlPr>
@@ -8470,7 +8558,7 @@
                     <m:sSub>
                       <m:sSubPr>
                         <m:ctrlPr>
-                          <a:rPr lang="en-US">
+                          <a:rPr lang="en-US" i="1">
                             <a:latin typeface="Cambria Math" panose="02040503050406030204" pitchFamily="18" charset="0"/>
                           </a:rPr>
                         </m:ctrlPr>
@@ -8503,7 +8591,7 @@
                     <m:sSup>
                       <m:sSupPr>
                         <m:ctrlPr>
-                          <a:rPr lang="en-US">
+                          <a:rPr lang="en-US" i="1">
                             <a:latin typeface="Cambria Math" panose="02040503050406030204" pitchFamily="18" charset="0"/>
                           </a:rPr>
                         </m:ctrlPr>
@@ -8567,7 +8655,7 @@
                     <m:sSub>
                       <m:sSubPr>
                         <m:ctrlPr>
-                          <a:rPr lang="en-US">
+                          <a:rPr lang="en-US" i="1">
                             <a:latin typeface="Cambria Math" panose="02040503050406030204" pitchFamily="18" charset="0"/>
                           </a:rPr>
                         </m:ctrlPr>
@@ -8700,7 +8788,7 @@
                     <m:sSub>
                       <m:sSubPr>
                         <m:ctrlPr>
-                          <a:rPr lang="en-US">
+                          <a:rPr lang="en-US" i="1">
                             <a:latin typeface="Cambria Math" panose="02040503050406030204" pitchFamily="18" charset="0"/>
                           </a:rPr>
                         </m:ctrlPr>
@@ -8778,7 +8866,7 @@
                     <m:sSub>
                       <m:sSubPr>
                         <m:ctrlPr>
-                          <a:rPr lang="en-US">
+                          <a:rPr lang="en-US" i="1">
                             <a:latin typeface="Cambria Math" panose="02040503050406030204" pitchFamily="18" charset="0"/>
                           </a:rPr>
                         </m:ctrlPr>
@@ -9124,7 +9212,7 @@
             </p:txBody>
           </p:sp>
         </mc:Choice>
-        <mc:Fallback>
+        <mc:Fallback xmlns="">
           <p:sp>
             <p:nvSpPr>
               <p:cNvPr id="3" name="Content Placeholder 2"/>
@@ -9306,8 +9394,8 @@
           </a:p>
         </p:txBody>
       </p:sp>
-      <mc:AlternateContent xmlns:mc="http://schemas.openxmlformats.org/markup-compatibility/2006">
-        <mc:Choice xmlns:a14="http://schemas.microsoft.com/office/drawing/2010/main" Requires="a14">
+      <mc:AlternateContent xmlns:mc="http://schemas.openxmlformats.org/markup-compatibility/2006" xmlns:a14="http://schemas.microsoft.com/office/drawing/2010/main">
+        <mc:Choice Requires="a14">
           <p:sp>
             <p:nvSpPr>
               <p:cNvPr id="3" name="Content Placeholder 2"/>
@@ -9480,7 +9568,7 @@
                     <m:sSub>
                       <m:sSubPr>
                         <m:ctrlPr>
-                          <a:rPr lang="en-US">
+                          <a:rPr lang="en-US" i="1">
                             <a:latin typeface="Cambria Math" panose="02040503050406030204" pitchFamily="18" charset="0"/>
                           </a:rPr>
                         </m:ctrlPr>
@@ -9553,7 +9641,7 @@
                       <m:sSub>
                         <m:sSubPr>
                           <m:ctrlPr>
-                            <a:rPr lang="en-US">
+                            <a:rPr lang="en-US" i="1">
                               <a:latin typeface="Cambria Math" panose="02040503050406030204" pitchFamily="18" charset="0"/>
                             </a:rPr>
                           </m:ctrlPr>
@@ -9841,7 +9929,7 @@
                       <m:sSub>
                         <m:sSubPr>
                           <m:ctrlPr>
-                            <a:rPr lang="en-US">
+                            <a:rPr lang="en-US" i="1">
                               <a:latin typeface="Cambria Math" panose="02040503050406030204" pitchFamily="18" charset="0"/>
                             </a:rPr>
                           </m:ctrlPr>
@@ -10126,7 +10214,7 @@
                     <m:sSub>
                       <m:sSubPr>
                         <m:ctrlPr>
-                          <a:rPr lang="en-US">
+                          <a:rPr lang="en-US" i="1">
                             <a:latin typeface="Cambria Math" panose="02040503050406030204" pitchFamily="18" charset="0"/>
                           </a:rPr>
                         </m:ctrlPr>
@@ -10159,7 +10247,7 @@
                     <m:sSup>
                       <m:sSupPr>
                         <m:ctrlPr>
-                          <a:rPr lang="en-US">
+                          <a:rPr lang="en-US" i="1">
                             <a:latin typeface="Cambria Math" panose="02040503050406030204" pitchFamily="18" charset="0"/>
                           </a:rPr>
                         </m:ctrlPr>
@@ -10193,7 +10281,7 @@
                       <m:fPr>
                         <m:type m:val="lin"/>
                         <m:ctrlPr>
-                          <a:rPr lang="en-US">
+                          <a:rPr lang="en-US" i="1">
                             <a:latin typeface="Cambria Math" panose="02040503050406030204" pitchFamily="18" charset="0"/>
                           </a:rPr>
                         </m:ctrlPr>
@@ -10242,7 +10330,7 @@
                     <m:sSub>
                       <m:sSubPr>
                         <m:ctrlPr>
-                          <a:rPr lang="en-US">
+                          <a:rPr lang="en-US" i="1">
                             <a:latin typeface="Cambria Math" panose="02040503050406030204" pitchFamily="18" charset="0"/>
                           </a:rPr>
                         </m:ctrlPr>
@@ -10306,7 +10394,7 @@
                     <m:sSub>
                       <m:sSubPr>
                         <m:ctrlPr>
-                          <a:rPr lang="en-US">
+                          <a:rPr lang="en-US" i="1">
                             <a:latin typeface="Cambria Math" panose="02040503050406030204" pitchFamily="18" charset="0"/>
                           </a:rPr>
                         </m:ctrlPr>
@@ -10339,7 +10427,7 @@
                     <m:sSub>
                       <m:sSubPr>
                         <m:ctrlPr>
-                          <a:rPr lang="en-US">
+                          <a:rPr lang="en-US" i="1">
                             <a:latin typeface="Cambria Math" panose="02040503050406030204" pitchFamily="18" charset="0"/>
                           </a:rPr>
                         </m:ctrlPr>
@@ -10403,7 +10491,7 @@
                     <m:sSub>
                       <m:sSubPr>
                         <m:ctrlPr>
-                          <a:rPr lang="en-US">
+                          <a:rPr lang="en-US" i="1">
                             <a:latin typeface="Cambria Math" panose="02040503050406030204" pitchFamily="18" charset="0"/>
                           </a:rPr>
                         </m:ctrlPr>
@@ -10435,7 +10523,7 @@
             </p:txBody>
           </p:sp>
         </mc:Choice>
-        <mc:Fallback>
+        <mc:Fallback xmlns="">
           <p:sp>
             <p:nvSpPr>
               <p:cNvPr id="3" name="Content Placeholder 2"/>
@@ -10554,8 +10642,8 @@
           </a:p>
         </p:txBody>
       </p:sp>
-      <mc:AlternateContent xmlns:mc="http://schemas.openxmlformats.org/markup-compatibility/2006">
-        <mc:Choice xmlns:a14="http://schemas.microsoft.com/office/drawing/2010/main" Requires="a14">
+      <mc:AlternateContent xmlns:mc="http://schemas.openxmlformats.org/markup-compatibility/2006" xmlns:a14="http://schemas.microsoft.com/office/drawing/2010/main">
+        <mc:Choice Requires="a14">
           <p:sp>
             <p:nvSpPr>
               <p:cNvPr id="3" name="Content Placeholder 2"/>
@@ -10846,7 +10934,7 @@
             </p:txBody>
           </p:sp>
         </mc:Choice>
-        <mc:Fallback>
+        <mc:Fallback xmlns="">
           <p:sp>
             <p:nvSpPr>
               <p:cNvPr id="3" name="Content Placeholder 2"/>
@@ -12985,8 +13073,8 @@
           </a:p>
         </p:txBody>
       </p:sp>
-      <mc:AlternateContent xmlns:mc="http://schemas.openxmlformats.org/markup-compatibility/2006">
-        <mc:Choice xmlns:a14="http://schemas.microsoft.com/office/drawing/2010/main" Requires="a14">
+      <mc:AlternateContent xmlns:mc="http://schemas.openxmlformats.org/markup-compatibility/2006" xmlns:a14="http://schemas.microsoft.com/office/drawing/2010/main">
+        <mc:Choice Requires="a14">
           <p:sp>
             <p:nvSpPr>
               <p:cNvPr id="3" name="Content Placeholder 2"/>
@@ -13017,7 +13105,7 @@
                       <m:fPr>
                         <m:type m:val="lin"/>
                         <m:ctrlPr>
-                          <a:rPr lang="en-US">
+                          <a:rPr lang="en-US" i="1">
                             <a:latin typeface="Cambria Math" panose="02040503050406030204" pitchFamily="18" charset="0"/>
                           </a:rPr>
                         </m:ctrlPr>
@@ -13064,7 +13152,7 @@
                     <m:f>
                       <m:fPr>
                         <m:ctrlPr>
-                          <a:rPr lang="en-US">
+                          <a:rPr lang="en-US" i="1">
                             <a:latin typeface="Cambria Math" panose="02040503050406030204" pitchFamily="18" charset="0"/>
                           </a:rPr>
                         </m:ctrlPr>
@@ -13314,7 +13402,7 @@
                     <m:f>
                       <m:fPr>
                         <m:ctrlPr>
-                          <a:rPr lang="en-US">
+                          <a:rPr lang="en-US" i="1">
                             <a:latin typeface="Cambria Math" panose="02040503050406030204" pitchFamily="18" charset="0"/>
                           </a:rPr>
                         </m:ctrlPr>
@@ -13395,7 +13483,7 @@
             </p:txBody>
           </p:sp>
         </mc:Choice>
-        <mc:Fallback>
+        <mc:Fallback xmlns="">
           <p:sp>
             <p:nvSpPr>
               <p:cNvPr id="3" name="Content Placeholder 2"/>
@@ -13522,8 +13610,8 @@
           </a:p>
         </p:txBody>
       </p:sp>
-      <mc:AlternateContent xmlns:mc="http://schemas.openxmlformats.org/markup-compatibility/2006">
-        <mc:Choice xmlns:a14="http://schemas.microsoft.com/office/drawing/2010/main" Requires="a14">
+      <mc:AlternateContent xmlns:mc="http://schemas.openxmlformats.org/markup-compatibility/2006" xmlns:a14="http://schemas.microsoft.com/office/drawing/2010/main">
+        <mc:Choice Requires="a14">
           <p:sp>
             <p:nvSpPr>
               <p:cNvPr id="3" name="Content Placeholder 2"/>
@@ -13563,7 +13651,7 @@
                     <m:sSub>
                       <m:sSubPr>
                         <m:ctrlPr>
-                          <a:rPr lang="en-US">
+                          <a:rPr lang="en-US" i="1">
                             <a:latin typeface="Cambria Math" panose="02040503050406030204" pitchFamily="18" charset="0"/>
                           </a:rPr>
                         </m:ctrlPr>
@@ -13819,7 +13907,7 @@
                       <m:sSub>
                         <m:sSubPr>
                           <m:ctrlPr>
-                            <a:rPr lang="en-US">
+                            <a:rPr lang="en-US" i="1">
                               <a:latin typeface="Cambria Math" panose="02040503050406030204" pitchFamily="18" charset="0"/>
                             </a:rPr>
                           </m:ctrlPr>
@@ -14380,7 +14468,7 @@
             </p:txBody>
           </p:sp>
         </mc:Choice>
-        <mc:Fallback>
+        <mc:Fallback xmlns="">
           <p:sp>
             <p:nvSpPr>
               <p:cNvPr id="3" name="Content Placeholder 2"/>
@@ -14535,7 +14623,15 @@
             </a:pPr>
             <a:r>
               <a:rPr dirty="0"/>
-              <a:t>Rq에서의 곱셈과 고전 알고리즘</a:t>
+              <a:t>R</a:t>
+            </a:r>
+            <a:r>
+              <a:rPr baseline="-25000" dirty="0"/>
+              <a:t>q</a:t>
+            </a:r>
+            <a:r>
+              <a:rPr dirty="0"/>
+              <a:t>에서의 곱셈과 고전 알고리즘</a:t>
             </a:r>
           </a:p>
           <a:p>
@@ -14669,8 +14765,8 @@
           </a:p>
         </p:txBody>
       </p:sp>
-      <mc:AlternateContent xmlns:mc="http://schemas.openxmlformats.org/markup-compatibility/2006">
-        <mc:Choice xmlns:a14="http://schemas.microsoft.com/office/drawing/2010/main" Requires="a14">
+      <mc:AlternateContent xmlns:mc="http://schemas.openxmlformats.org/markup-compatibility/2006" xmlns:a14="http://schemas.microsoft.com/office/drawing/2010/main">
+        <mc:Choice Requires="a14">
           <p:sp>
             <p:nvSpPr>
               <p:cNvPr id="3" name="Content Placeholder 2"/>
@@ -14756,7 +14852,7 @@
                     <m:sSup>
                       <m:sSupPr>
                         <m:ctrlPr>
-                          <a:rPr lang="en-US">
+                          <a:rPr lang="en-US" i="1">
                             <a:latin typeface="Cambria Math" panose="02040503050406030204" pitchFamily="18" charset="0"/>
                           </a:rPr>
                         </m:ctrlPr>
@@ -14804,7 +14900,7 @@
                       <m:sSup>
                         <m:sSupPr>
                           <m:ctrlPr>
-                            <a:rPr lang="en-US">
+                            <a:rPr lang="en-US" i="1">
                               <a:latin typeface="Cambria Math" panose="02040503050406030204" pitchFamily="18" charset="0"/>
                             </a:rPr>
                           </m:ctrlPr>
@@ -15435,7 +15531,7 @@
                     <m:sSub>
                       <m:sSubPr>
                         <m:ctrlPr>
-                          <a:rPr lang="en-US">
+                          <a:rPr lang="en-US" i="1">
                             <a:latin typeface="Cambria Math" panose="02040503050406030204" pitchFamily="18" charset="0"/>
                           </a:rPr>
                         </m:ctrlPr>
@@ -15520,7 +15616,7 @@
                       <m:sSub>
                         <m:sSubPr>
                           <m:ctrlPr>
-                            <a:rPr lang="en-US">
+                            <a:rPr lang="en-US" i="1">
                               <a:latin typeface="Cambria Math" panose="02040503050406030204" pitchFamily="18" charset="0"/>
                             </a:rPr>
                           </m:ctrlPr>
@@ -15711,7 +15807,7 @@
             </p:txBody>
           </p:sp>
         </mc:Choice>
-        <mc:Fallback>
+        <mc:Fallback xmlns="">
           <p:sp>
             <p:nvSpPr>
               <p:cNvPr id="3" name="Content Placeholder 2"/>
@@ -15830,8 +15926,8 @@
           </a:p>
         </p:txBody>
       </p:sp>
-      <mc:AlternateContent xmlns:mc="http://schemas.openxmlformats.org/markup-compatibility/2006">
-        <mc:Choice xmlns:a14="http://schemas.microsoft.com/office/drawing/2010/main" Requires="a14">
+      <mc:AlternateContent xmlns:mc="http://schemas.openxmlformats.org/markup-compatibility/2006" xmlns:a14="http://schemas.microsoft.com/office/drawing/2010/main">
+        <mc:Choice Requires="a14">
           <p:sp>
             <p:nvSpPr>
               <p:cNvPr id="3" name="Content Placeholder 2"/>
@@ -15861,7 +15957,7 @@
                     <m:sSup>
                       <m:sSupPr>
                         <m:ctrlPr>
-                          <a:rPr lang="en-US">
+                          <a:rPr lang="en-US" i="1">
                             <a:latin typeface="Cambria Math" panose="02040503050406030204" pitchFamily="18" charset="0"/>
                           </a:rPr>
                         </m:ctrlPr>
@@ -15940,7 +16036,7 @@
                     <m:sSub>
                       <m:sSubPr>
                         <m:ctrlPr>
-                          <a:rPr lang="en-US">
+                          <a:rPr lang="en-US" i="1">
                             <a:latin typeface="Cambria Math" panose="02040503050406030204" pitchFamily="18" charset="0"/>
                           </a:rPr>
                         </m:ctrlPr>
@@ -16367,7 +16463,7 @@
             </p:txBody>
           </p:sp>
         </mc:Choice>
-        <mc:Fallback>
+        <mc:Fallback xmlns="">
           <p:sp>
             <p:nvSpPr>
               <p:cNvPr id="3" name="Content Placeholder 2"/>
@@ -16486,8 +16582,8 @@
           </a:p>
         </p:txBody>
       </p:sp>
-      <mc:AlternateContent xmlns:mc="http://schemas.openxmlformats.org/markup-compatibility/2006">
-        <mc:Choice xmlns:a14="http://schemas.microsoft.com/office/drawing/2010/main" Requires="a14">
+      <mc:AlternateContent xmlns:mc="http://schemas.openxmlformats.org/markup-compatibility/2006" xmlns:a14="http://schemas.microsoft.com/office/drawing/2010/main">
+        <mc:Choice Requires="a14">
           <p:sp>
             <p:nvSpPr>
               <p:cNvPr id="3" name="Content Placeholder 2"/>
@@ -16527,7 +16623,7 @@
                         <m:accPr>
                           <m:chr m:val="̂"/>
                           <m:ctrlPr>
-                            <a:rPr lang="en-US">
+                            <a:rPr lang="en-US" i="1">
                               <a:latin typeface="Cambria Math" panose="02040503050406030204" pitchFamily="18" charset="0"/>
                             </a:rPr>
                           </m:ctrlPr>
@@ -16960,7 +17056,7 @@
                     <m:sSup>
                       <m:sSupPr>
                         <m:ctrlPr>
-                          <a:rPr lang="en-US">
+                          <a:rPr lang="en-US" i="1">
                             <a:latin typeface="Cambria Math" panose="02040503050406030204" pitchFamily="18" charset="0"/>
                           </a:rPr>
                         </m:ctrlPr>
@@ -16998,7 +17094,7 @@
             </p:txBody>
           </p:sp>
         </mc:Choice>
-        <mc:Fallback>
+        <mc:Fallback xmlns="">
           <p:sp>
             <p:nvSpPr>
               <p:cNvPr id="3" name="Content Placeholder 2"/>
@@ -17460,8 +17556,8 @@
           </a:p>
         </p:txBody>
       </p:sp>
-      <mc:AlternateContent xmlns:mc="http://schemas.openxmlformats.org/markup-compatibility/2006">
-        <mc:Choice xmlns:a14="http://schemas.microsoft.com/office/drawing/2010/main" Requires="a14">
+      <mc:AlternateContent xmlns:mc="http://schemas.openxmlformats.org/markup-compatibility/2006" xmlns:a14="http://schemas.microsoft.com/office/drawing/2010/main">
+        <mc:Choice Requires="a14">
           <p:sp>
             <p:nvSpPr>
               <p:cNvPr id="3" name="Content Placeholder 2"/>
@@ -17687,7 +17783,7 @@
                     <m:sSub>
                       <m:sSubPr>
                         <m:ctrlPr>
-                          <a:rPr lang="en-US">
+                          <a:rPr lang="en-US" i="1">
                             <a:latin typeface="Cambria Math" panose="02040503050406030204" pitchFamily="18" charset="0"/>
                           </a:rPr>
                         </m:ctrlPr>
@@ -18032,7 +18128,7 @@
             </p:txBody>
           </p:sp>
         </mc:Choice>
-        <mc:Fallback>
+        <mc:Fallback xmlns="">
           <p:sp>
             <p:nvSpPr>
               <p:cNvPr id="3" name="Content Placeholder 2"/>
@@ -19002,8 +19098,8 @@
           </a:p>
         </p:txBody>
       </p:sp>
-      <mc:AlternateContent xmlns:mc="http://schemas.openxmlformats.org/markup-compatibility/2006">
-        <mc:Choice xmlns:a14="http://schemas.microsoft.com/office/drawing/2010/main" Requires="a14">
+      <mc:AlternateContent xmlns:mc="http://schemas.openxmlformats.org/markup-compatibility/2006" xmlns:a14="http://schemas.microsoft.com/office/drawing/2010/main">
+        <mc:Choice Requires="a14">
           <p:sp>
             <p:nvSpPr>
               <p:cNvPr id="3" name="Content Placeholder 2"/>
@@ -19068,7 +19164,7 @@
                     <m:sSub>
                       <m:sSubPr>
                         <m:ctrlPr>
-                          <a:rPr lang="en-US">
+                          <a:rPr lang="en-US" i="1">
                             <a:latin typeface="Cambria Math" panose="02040503050406030204" pitchFamily="18" charset="0"/>
                           </a:rPr>
                         </m:ctrlPr>
@@ -19663,7 +19759,7 @@
             </p:txBody>
           </p:sp>
         </mc:Choice>
-        <mc:Fallback>
+        <mc:Fallback xmlns="">
           <p:sp>
             <p:nvSpPr>
               <p:cNvPr id="3" name="Content Placeholder 2"/>
@@ -19812,8 +19908,8 @@
           </a:p>
         </p:txBody>
       </p:sp>
-      <mc:AlternateContent xmlns:mc="http://schemas.openxmlformats.org/markup-compatibility/2006">
-        <mc:Choice xmlns:a14="http://schemas.microsoft.com/office/drawing/2010/main" Requires="a14">
+      <mc:AlternateContent xmlns:mc="http://schemas.openxmlformats.org/markup-compatibility/2006" xmlns:a14="http://schemas.microsoft.com/office/drawing/2010/main">
+        <mc:Choice Requires="a14">
           <p:sp>
             <p:nvSpPr>
               <p:cNvPr id="3" name="Content Placeholder 2"/>
@@ -20114,7 +20210,7 @@
                     <m:sSub>
                       <m:sSubPr>
                         <m:ctrlPr>
-                          <a:rPr lang="en-US">
+                          <a:rPr lang="en-US" i="1">
                             <a:latin typeface="Cambria Math" panose="02040503050406030204" pitchFamily="18" charset="0"/>
                           </a:rPr>
                         </m:ctrlPr>
@@ -20239,7 +20335,7 @@
             </p:txBody>
           </p:sp>
         </mc:Choice>
-        <mc:Fallback>
+        <mc:Fallback xmlns="">
           <p:sp>
             <p:nvSpPr>
               <p:cNvPr id="3" name="Content Placeholder 2"/>
@@ -21165,8 +21261,8 @@
           </a:p>
         </p:txBody>
       </p:sp>
-      <mc:AlternateContent xmlns:mc="http://schemas.openxmlformats.org/markup-compatibility/2006">
-        <mc:Choice xmlns:a14="http://schemas.microsoft.com/office/drawing/2010/main" Requires="a14">
+      <mc:AlternateContent xmlns:mc="http://schemas.openxmlformats.org/markup-compatibility/2006" xmlns:a14="http://schemas.microsoft.com/office/drawing/2010/main">
+        <mc:Choice Requires="a14">
           <p:sp>
             <p:nvSpPr>
               <p:cNvPr id="3" name="Content Placeholder 2"/>
@@ -21262,7 +21358,7 @@
                     <m:f>
                       <m:fPr>
                         <m:ctrlPr>
-                          <a:rPr lang="en-US">
+                          <a:rPr lang="en-US" i="1">
                             <a:latin typeface="Cambria Math" panose="02040503050406030204" pitchFamily="18" charset="0"/>
                           </a:rPr>
                         </m:ctrlPr>
@@ -21377,7 +21473,7 @@
                       <m:accPr>
                         <m:chr m:val="̂"/>
                         <m:ctrlPr>
-                          <a:rPr lang="en-US">
+                          <a:rPr lang="en-US" i="1">
                             <a:latin typeface="Cambria Math" panose="02040503050406030204" pitchFamily="18" charset="0"/>
                           </a:rPr>
                         </m:ctrlPr>
@@ -21485,7 +21581,7 @@
             </p:txBody>
           </p:sp>
         </mc:Choice>
-        <mc:Fallback>
+        <mc:Fallback xmlns="">
           <p:sp>
             <p:nvSpPr>
               <p:cNvPr id="3" name="Content Placeholder 2"/>
@@ -22179,15 +22275,7 @@
                       </a:r>
                       <a:r>
                         <a:rPr sz="1800" baseline="30000" dirty="0"/>
-                        <a:t>21</a:t>
-                      </a:r>
-                      <a:r>
-                        <a:rPr sz="1800" dirty="0"/>
-                        <a:t>·</a:t>
-                      </a:r>
-                      <a:r>
-                        <a:rPr sz="1800" baseline="30000" dirty="0"/>
-                        <a:t>8</a:t>
+                        <a:t>21.8</a:t>
                       </a:r>
                       <a:r>
                         <a:rPr sz="1800" dirty="0"/>
@@ -22246,15 +22334,7 @@
                       </a:r>
                       <a:r>
                         <a:rPr sz="1800" baseline="30000" dirty="0"/>
-                        <a:t>14</a:t>
-                      </a:r>
-                      <a:r>
-                        <a:rPr sz="1800" dirty="0"/>
-                        <a:t>·</a:t>
-                      </a:r>
-                      <a:r>
-                        <a:rPr sz="1800" baseline="30000" dirty="0"/>
-                        <a:t>9</a:t>
+                        <a:t>14.9</a:t>
                       </a:r>
                       <a:r>
                         <a:rPr sz="1800" dirty="0"/>
@@ -22422,15 +22502,7 @@
                       </a:r>
                       <a:r>
                         <a:rPr sz="1800" baseline="30000" dirty="0"/>
-                        <a:t>6</a:t>
-                      </a:r>
-                      <a:r>
-                        <a:rPr sz="1800" dirty="0"/>
-                        <a:t>·</a:t>
-                      </a:r>
-                      <a:r>
-                        <a:rPr sz="1800" baseline="30000" dirty="0"/>
-                        <a:t>9</a:t>
+                        <a:t>6.9</a:t>
                       </a:r>
                       <a:r>
                         <a:rPr sz="1800" dirty="0"/>
@@ -25783,8 +25855,8 @@
           </a:p>
         </p:txBody>
       </p:sp>
-      <mc:AlternateContent xmlns:mc="http://schemas.openxmlformats.org/markup-compatibility/2006">
-        <mc:Choice xmlns:a14="http://schemas.microsoft.com/office/drawing/2010/main" Requires="a14">
+      <mc:AlternateContent xmlns:mc="http://schemas.openxmlformats.org/markup-compatibility/2006" xmlns:a14="http://schemas.microsoft.com/office/drawing/2010/main">
+        <mc:Choice Requires="a14">
           <p:sp>
             <p:nvSpPr>
               <p:cNvPr id="3" name="Content Placeholder 2"/>
@@ -25810,7 +25882,7 @@
                     <m:sSub>
                       <m:sSubPr>
                         <m:ctrlPr>
-                          <a:rPr lang="en-US">
+                          <a:rPr lang="en-US" i="1">
                             <a:latin typeface="Cambria Math" panose="02040503050406030204" pitchFamily="18" charset="0"/>
                           </a:rPr>
                         </m:ctrlPr>
@@ -25843,7 +25915,7 @@
                     <m:sSub>
                       <m:sSubPr>
                         <m:ctrlPr>
-                          <a:rPr lang="en-US">
+                          <a:rPr lang="en-US" i="1">
                             <a:latin typeface="Cambria Math" panose="02040503050406030204" pitchFamily="18" charset="0"/>
                           </a:rPr>
                         </m:ctrlPr>
@@ -26165,7 +26237,7 @@
                     <m:sSup>
                       <m:sSupPr>
                         <m:ctrlPr>
-                          <a:rPr lang="en-US">
+                          <a:rPr lang="en-US" i="1">
                             <a:latin typeface="Cambria Math" panose="02040503050406030204" pitchFamily="18" charset="0"/>
                           </a:rPr>
                         </m:ctrlPr>
@@ -26919,7 +26991,7 @@
                     <m:sSub>
                       <m:sSubPr>
                         <m:ctrlPr>
-                          <a:rPr lang="en-US">
+                          <a:rPr lang="en-US" i="1">
                             <a:latin typeface="Cambria Math" panose="02040503050406030204" pitchFamily="18" charset="0"/>
                           </a:rPr>
                         </m:ctrlPr>
@@ -26952,7 +27024,7 @@
                     <m:sSub>
                       <m:sSubPr>
                         <m:ctrlPr>
-                          <a:rPr lang="en-US">
+                          <a:rPr lang="en-US" i="1">
                             <a:latin typeface="Cambria Math" panose="02040503050406030204" pitchFamily="18" charset="0"/>
                           </a:rPr>
                         </m:ctrlPr>
@@ -27332,7 +27404,7 @@
             </p:txBody>
           </p:sp>
         </mc:Choice>
-        <mc:Fallback>
+        <mc:Fallback xmlns="">
           <p:sp>
             <p:nvSpPr>
               <p:cNvPr id="3" name="Content Placeholder 2"/>
@@ -28560,8 +28632,8 @@
         </p:nvSpPr>
         <p:spPr>
           <a:xfrm>
-            <a:off x="838200" y="3429000"/>
-            <a:ext cx="10515600" cy="2567411"/>
+            <a:off x="838200" y="3978442"/>
+            <a:ext cx="10515600" cy="2017969"/>
           </a:xfrm>
         </p:spPr>
         <p:txBody>
@@ -28663,8 +28735,55 @@
         </p:blipFill>
         <p:spPr bwMode="auto">
           <a:xfrm>
-            <a:off x="3571875" y="1295322"/>
+            <a:off x="6305550" y="1295322"/>
             <a:ext cx="5048250" cy="1828800"/>
+          </a:xfrm>
+          <a:prstGeom prst="rect">
+            <a:avLst/>
+          </a:prstGeom>
+          <a:noFill/>
+          <a:extLst>
+            <a:ext uri="{909E8E84-426E-40DD-AFC4-6F175D3DCCD1}">
+              <a14:hiddenFill xmlns:a14="http://schemas.microsoft.com/office/drawing/2010/main">
+                <a:solidFill>
+                  <a:srgbClr val="FFFFFF"/>
+                </a:solidFill>
+              </a14:hiddenFill>
+            </a:ext>
+          </a:extLst>
+        </p:spPr>
+      </p:pic>
+      <p:pic>
+        <p:nvPicPr>
+          <p:cNvPr id="4" name="Picture 4">
+            <a:extLst>
+              <a:ext uri="{FF2B5EF4-FFF2-40B4-BE49-F238E27FC236}">
+                <a16:creationId xmlns:a16="http://schemas.microsoft.com/office/drawing/2014/main" id="{E4806A7D-5C10-9594-9E9E-65EFF20564BD}"/>
+              </a:ext>
+            </a:extLst>
+          </p:cNvPr>
+          <p:cNvPicPr>
+            <a:picLocks noChangeAspect="1" noChangeArrowheads="1"/>
+          </p:cNvPicPr>
+          <p:nvPr/>
+        </p:nvPicPr>
+        <p:blipFill>
+          <a:blip r:embed="rId3">
+            <a:extLst>
+              <a:ext uri="{28A0092B-C50C-407E-A947-70E740481C1C}">
+                <a14:useLocalDpi xmlns:a14="http://schemas.microsoft.com/office/drawing/2010/main" val="0"/>
+              </a:ext>
+            </a:extLst>
+          </a:blip>
+          <a:srcRect/>
+          <a:stretch>
+            <a:fillRect/>
+          </a:stretch>
+        </p:blipFill>
+        <p:spPr bwMode="auto">
+          <a:xfrm>
+            <a:off x="838200" y="1295322"/>
+            <a:ext cx="5191125" cy="2495550"/>
           </a:xfrm>
           <a:prstGeom prst="rect">
             <a:avLst/>
@@ -28741,8 +28860,8 @@
           </a:p>
         </p:txBody>
       </p:sp>
-      <mc:AlternateContent xmlns:mc="http://schemas.openxmlformats.org/markup-compatibility/2006">
-        <mc:Choice xmlns:a14="http://schemas.microsoft.com/office/drawing/2010/main" Requires="a14">
+      <mc:AlternateContent xmlns:mc="http://schemas.openxmlformats.org/markup-compatibility/2006" xmlns:a14="http://schemas.microsoft.com/office/drawing/2010/main">
+        <mc:Choice Requires="a14">
           <p:sp>
             <p:nvSpPr>
               <p:cNvPr id="3" name="Content Placeholder 2"/>
@@ -28772,7 +28891,7 @@
                     <m:sSub>
                       <m:sSubPr>
                         <m:ctrlPr>
-                          <a:rPr lang="en-US">
+                          <a:rPr lang="en-US" i="1">
                             <a:latin typeface="Cambria Math" panose="02040503050406030204" pitchFamily="18" charset="0"/>
                           </a:rPr>
                         </m:ctrlPr>
@@ -29047,7 +29166,7 @@
                     <m:sSub>
                       <m:sSubPr>
                         <m:ctrlPr>
-                          <a:rPr lang="en-US">
+                          <a:rPr lang="en-US" i="1">
                             <a:latin typeface="Cambria Math" panose="02040503050406030204" pitchFamily="18" charset="0"/>
                           </a:rPr>
                         </m:ctrlPr>
@@ -29651,7 +29770,7 @@
                     <m:sSub>
                       <m:sSubPr>
                         <m:ctrlPr>
-                          <a:rPr lang="en-US">
+                          <a:rPr lang="en-US" i="1">
                             <a:latin typeface="Cambria Math" panose="02040503050406030204" pitchFamily="18" charset="0"/>
                           </a:rPr>
                         </m:ctrlPr>
@@ -29832,7 +29951,7 @@
                     <m:sSub>
                       <m:sSubPr>
                         <m:ctrlPr>
-                          <a:rPr lang="en-US">
+                          <a:rPr lang="en-US" i="1">
                             <a:latin typeface="Cambria Math" panose="02040503050406030204" pitchFamily="18" charset="0"/>
                           </a:rPr>
                         </m:ctrlPr>
@@ -29864,7 +29983,7 @@
             </p:txBody>
           </p:sp>
         </mc:Choice>
-        <mc:Fallback>
+        <mc:Fallback xmlns="">
           <p:sp>
             <p:nvSpPr>
               <p:cNvPr id="3" name="Content Placeholder 2"/>
@@ -30038,8 +30157,8 @@
           </a:p>
         </p:txBody>
       </p:sp>
-      <mc:AlternateContent xmlns:mc="http://schemas.openxmlformats.org/markup-compatibility/2006">
-        <mc:Choice xmlns:a14="http://schemas.microsoft.com/office/drawing/2010/main" Requires="a14">
+      <mc:AlternateContent xmlns:mc="http://schemas.openxmlformats.org/markup-compatibility/2006" xmlns:a14="http://schemas.microsoft.com/office/drawing/2010/main">
+        <mc:Choice Requires="a14">
           <p:sp>
             <p:nvSpPr>
               <p:cNvPr id="3" name="Content Placeholder 2"/>
@@ -30249,7 +30368,7 @@
                     <m:sSub>
                       <m:sSubPr>
                         <m:ctrlPr>
-                          <a:rPr lang="en-US">
+                          <a:rPr lang="en-US" i="1">
                             <a:latin typeface="Cambria Math" panose="02040503050406030204" pitchFamily="18" charset="0"/>
                           </a:rPr>
                         </m:ctrlPr>
@@ -30297,7 +30416,7 @@
                     <m:sSup>
                       <m:sSupPr>
                         <m:ctrlPr>
-                          <a:rPr lang="en-US">
+                          <a:rPr lang="en-US" i="1">
                             <a:latin typeface="Cambria Math" panose="02040503050406030204" pitchFamily="18" charset="0"/>
                           </a:rPr>
                         </m:ctrlPr>
@@ -30374,7 +30493,7 @@
             </p:txBody>
           </p:sp>
         </mc:Choice>
-        <mc:Fallback>
+        <mc:Fallback xmlns="">
           <p:sp>
             <p:nvSpPr>
               <p:cNvPr id="3" name="Content Placeholder 2"/>
@@ -30501,8 +30620,8 @@
           </a:p>
         </p:txBody>
       </p:sp>
-      <mc:AlternateContent xmlns:mc="http://schemas.openxmlformats.org/markup-compatibility/2006">
-        <mc:Choice xmlns:a14="http://schemas.microsoft.com/office/drawing/2010/main" Requires="a14">
+      <mc:AlternateContent xmlns:mc="http://schemas.openxmlformats.org/markup-compatibility/2006" xmlns:a14="http://schemas.microsoft.com/office/drawing/2010/main">
+        <mc:Choice Requires="a14">
           <p:sp>
             <p:nvSpPr>
               <p:cNvPr id="3" name="Content Placeholder 2"/>
@@ -30588,7 +30707,7 @@
                     <m:sSup>
                       <m:sSupPr>
                         <m:ctrlPr>
-                          <a:rPr lang="en-US">
+                          <a:rPr lang="en-US" i="1">
                             <a:latin typeface="Cambria Math" panose="02040503050406030204" pitchFamily="18" charset="0"/>
                           </a:rPr>
                         </m:ctrlPr>
@@ -31021,7 +31140,7 @@
                     <m:sSub>
                       <m:sSubPr>
                         <m:ctrlPr>
-                          <a:rPr lang="en-US">
+                          <a:rPr lang="en-US" i="1">
                             <a:latin typeface="Cambria Math" panose="02040503050406030204" pitchFamily="18" charset="0"/>
                           </a:rPr>
                         </m:ctrlPr>
@@ -31103,7 +31222,7 @@
                     <m:sSup>
                       <m:sSupPr>
                         <m:ctrlPr>
-                          <a:rPr lang="en-US">
+                          <a:rPr lang="en-US" i="1">
                             <a:latin typeface="Cambria Math" panose="02040503050406030204" pitchFamily="18" charset="0"/>
                           </a:rPr>
                         </m:ctrlPr>
@@ -31142,7 +31261,7 @@
                     <m:sSup>
                       <m:sSupPr>
                         <m:ctrlPr>
-                          <a:rPr lang="en-US">
+                          <a:rPr lang="en-US" i="1">
                             <a:latin typeface="Cambria Math" panose="02040503050406030204" pitchFamily="18" charset="0"/>
                           </a:rPr>
                         </m:ctrlPr>
@@ -31184,7 +31303,7 @@
                       <m:sSub>
                         <m:sSubPr>
                           <m:ctrlPr>
-                            <a:rPr lang="en-US">
+                            <a:rPr lang="en-US" i="1">
                               <a:latin typeface="Cambria Math" panose="02040503050406030204" pitchFamily="18" charset="0"/>
                             </a:rPr>
                           </m:ctrlPr>
@@ -31375,7 +31494,7 @@
             </p:txBody>
           </p:sp>
         </mc:Choice>
-        <mc:Fallback>
+        <mc:Fallback xmlns="">
           <p:sp>
             <p:nvSpPr>
               <p:cNvPr id="3" name="Content Placeholder 2"/>
@@ -31502,8 +31621,8 @@
           </a:p>
         </p:txBody>
       </p:sp>
-      <mc:AlternateContent xmlns:mc="http://schemas.openxmlformats.org/markup-compatibility/2006">
-        <mc:Choice xmlns:a14="http://schemas.microsoft.com/office/drawing/2010/main" Requires="a14">
+      <mc:AlternateContent xmlns:mc="http://schemas.openxmlformats.org/markup-compatibility/2006" xmlns:a14="http://schemas.microsoft.com/office/drawing/2010/main">
+        <mc:Choice Requires="a14">
           <p:sp>
             <p:nvSpPr>
               <p:cNvPr id="3" name="Content Placeholder 2"/>
@@ -31533,7 +31652,7 @@
                     <m:sSub>
                       <m:sSubPr>
                         <m:ctrlPr>
-                          <a:rPr lang="en-US">
+                          <a:rPr lang="en-US" i="1">
                             <a:latin typeface="Cambria Math" panose="02040503050406030204" pitchFamily="18" charset="0"/>
                           </a:rPr>
                         </m:ctrlPr>
@@ -31615,7 +31734,7 @@
                     <m:sSub>
                       <m:sSubPr>
                         <m:ctrlPr>
-                          <a:rPr lang="en-US">
+                          <a:rPr lang="en-US" i="1">
                             <a:latin typeface="Cambria Math" panose="02040503050406030204" pitchFamily="18" charset="0"/>
                           </a:rPr>
                         </m:ctrlPr>
@@ -31647,7 +31766,7 @@
             </p:txBody>
           </p:sp>
         </mc:Choice>
-        <mc:Fallback>
+        <mc:Fallback xmlns="">
           <p:sp>
             <p:nvSpPr>
               <p:cNvPr id="3" name="Content Placeholder 2"/>
@@ -33055,8 +33174,8 @@
           </a:p>
         </p:txBody>
       </p:sp>
-      <mc:AlternateContent xmlns:mc="http://schemas.openxmlformats.org/markup-compatibility/2006">
-        <mc:Choice xmlns:a14="http://schemas.microsoft.com/office/drawing/2010/main" Requires="a14">
+      <mc:AlternateContent xmlns:mc="http://schemas.openxmlformats.org/markup-compatibility/2006" xmlns:a14="http://schemas.microsoft.com/office/drawing/2010/main">
+        <mc:Choice Requires="a14">
           <p:sp>
             <p:nvSpPr>
               <p:cNvPr id="3" name="Content Placeholder 2"/>
@@ -33082,7 +33201,7 @@
                     <m:sSub>
                       <m:sSubPr>
                         <m:ctrlPr>
-                          <a:rPr lang="en-US">
+                          <a:rPr lang="en-US" i="1">
                             <a:latin typeface="Cambria Math" panose="02040503050406030204" pitchFamily="18" charset="0"/>
                           </a:rPr>
                         </m:ctrlPr>
@@ -33246,7 +33365,7 @@
                       <m:sSub>
                         <m:sSubPr>
                           <m:ctrlPr>
-                            <a:rPr lang="en-US">
+                            <a:rPr lang="en-US" i="1">
                               <a:latin typeface="Cambria Math" panose="02040503050406030204" pitchFamily="18" charset="0"/>
                             </a:rPr>
                           </m:ctrlPr>
@@ -33551,7 +33670,7 @@
                       <m:sSub>
                         <m:sSubPr>
                           <m:ctrlPr>
-                            <a:rPr lang="en-US">
+                            <a:rPr lang="en-US" i="1">
                               <a:latin typeface="Cambria Math" panose="02040503050406030204" pitchFamily="18" charset="0"/>
                             </a:rPr>
                           </m:ctrlPr>
@@ -33856,7 +33975,7 @@
                       <m:accPr>
                         <m:chr m:val="̂"/>
                         <m:ctrlPr>
-                          <a:rPr lang="en-US">
+                          <a:rPr lang="en-US" i="1">
                             <a:latin typeface="Cambria Math" panose="02040503050406030204" pitchFamily="18" charset="0"/>
                           </a:rPr>
                         </m:ctrlPr>
@@ -34279,7 +34398,7 @@
             </p:txBody>
           </p:sp>
         </mc:Choice>
-        <mc:Fallback>
+        <mc:Fallback xmlns="">
           <p:sp>
             <p:nvSpPr>
               <p:cNvPr id="3" name="Content Placeholder 2"/>
@@ -36430,8 +36549,8 @@
           </a:p>
         </p:txBody>
       </p:sp>
-      <mc:AlternateContent xmlns:mc="http://schemas.openxmlformats.org/markup-compatibility/2006">
-        <mc:Choice xmlns:a14="http://schemas.microsoft.com/office/drawing/2010/main" Requires="a14">
+      <mc:AlternateContent xmlns:mc="http://schemas.openxmlformats.org/markup-compatibility/2006" xmlns:a14="http://schemas.microsoft.com/office/drawing/2010/main">
+        <mc:Choice Requires="a14">
           <p:sp>
             <p:nvSpPr>
               <p:cNvPr id="3" name="Content Placeholder 2"/>
@@ -36471,7 +36590,7 @@
                     <m:sSub>
                       <m:sSubPr>
                         <m:ctrlPr>
-                          <a:rPr lang="en-US">
+                          <a:rPr lang="en-US" i="1">
                             <a:latin typeface="Cambria Math" panose="02040503050406030204" pitchFamily="18" charset="0"/>
                           </a:rPr>
                         </m:ctrlPr>
@@ -36548,7 +36667,7 @@
                     <m:sSup>
                       <m:sSupPr>
                         <m:ctrlPr>
-                          <a:rPr lang="en-US">
+                          <a:rPr lang="en-US" i="1">
                             <a:latin typeface="Cambria Math" panose="02040503050406030204" pitchFamily="18" charset="0"/>
                           </a:rPr>
                         </m:ctrlPr>
@@ -36679,7 +36798,7 @@
                     <m:sSup>
                       <m:sSupPr>
                         <m:ctrlPr>
-                          <a:rPr lang="en-US">
+                          <a:rPr lang="en-US" i="1">
                             <a:latin typeface="Cambria Math" panose="02040503050406030204" pitchFamily="18" charset="0"/>
                           </a:rPr>
                         </m:ctrlPr>
@@ -36752,7 +36871,7 @@
                     <m:sSub>
                       <m:sSubPr>
                         <m:ctrlPr>
-                          <a:rPr lang="en-US">
+                          <a:rPr lang="en-US" i="1">
                             <a:latin typeface="Cambria Math" panose="02040503050406030204" pitchFamily="18" charset="0"/>
                           </a:rPr>
                         </m:ctrlPr>
@@ -36784,7 +36903,7 @@
             </p:txBody>
           </p:sp>
         </mc:Choice>
-        <mc:Fallback>
+        <mc:Fallback xmlns="">
           <p:sp>
             <p:nvSpPr>
               <p:cNvPr id="3" name="Content Placeholder 2"/>
@@ -37614,8 +37733,8 @@
           </a:p>
         </p:txBody>
       </p:sp>
-      <mc:AlternateContent xmlns:mc="http://schemas.openxmlformats.org/markup-compatibility/2006">
-        <mc:Choice xmlns:a14="http://schemas.microsoft.com/office/drawing/2010/main" Requires="a14">
+      <mc:AlternateContent xmlns:mc="http://schemas.openxmlformats.org/markup-compatibility/2006" xmlns:a14="http://schemas.microsoft.com/office/drawing/2010/main">
+        <mc:Choice Requires="a14">
           <p:sp>
             <p:nvSpPr>
               <p:cNvPr id="3" name="Content Placeholder 2"/>
@@ -37666,7 +37785,7 @@
                       <m:accPr>
                         <m:chr m:val="̂"/>
                         <m:ctrlPr>
-                          <a:rPr lang="en-US">
+                          <a:rPr lang="en-US" i="1">
                             <a:latin typeface="Cambria Math" panose="02040503050406030204" pitchFamily="18" charset="0"/>
                           </a:rPr>
                         </m:ctrlPr>
@@ -37714,7 +37833,7 @@
               <a:p>
                 <a:r>
                   <a:rPr dirty="0"/>
-                  <a:t>성분별 곱은 </a:t>
+                  <a:t>성분별 곱은 같은 </a:t>
                 </a:r>
                 <a14:m>
                   <m:oMath xmlns:m="http://schemas.openxmlformats.org/officeDocument/2006/math">
@@ -37746,14 +37865,14 @@
                 </a14:m>
                 <a:r>
                   <a:rPr dirty="0"/>
-                  <a:t>이 아니다 — </a:t>
+                  <a:t>이어도 Dilithium보다 상수가 크다 — </a:t>
                 </a:r>
                 <a14:m>
                   <m:oMath xmlns:m="http://schemas.openxmlformats.org/officeDocument/2006/math">
                     <m:sSub>
                       <m:sSubPr>
                         <m:ctrlPr>
-                          <a:rPr lang="en-US">
+                          <a:rPr lang="en-US" i="1">
                             <a:latin typeface="Cambria Math" panose="02040503050406030204" pitchFamily="18" charset="0"/>
                           </a:rPr>
                         </m:ctrlPr>
@@ -37786,7 +37905,7 @@
                     <m:sSub>
                       <m:sSubPr>
                         <m:ctrlPr>
-                          <a:rPr lang="en-US">
+                          <a:rPr lang="en-US" i="1">
                             <a:latin typeface="Cambria Math" panose="02040503050406030204" pitchFamily="18" charset="0"/>
                           </a:rPr>
                         </m:ctrlPr>
@@ -37820,7 +37939,7 @@
                       <m:fPr>
                         <m:type m:val="lin"/>
                         <m:ctrlPr>
-                          <a:rPr lang="en-US">
+                          <a:rPr lang="en-US" i="1">
                             <a:latin typeface="Cambria Math" panose="02040503050406030204" pitchFamily="18" charset="0"/>
                           </a:rPr>
                         </m:ctrlPr>
@@ -37884,7 +38003,7 @@
             </p:txBody>
           </p:sp>
         </mc:Choice>
-        <mc:Fallback>
+        <mc:Fallback xmlns="">
           <p:sp>
             <p:nvSpPr>
               <p:cNvPr id="3" name="Content Placeholder 2"/>
@@ -37960,13 +38079,13 @@
           <p:nvPr>
             <p:extLst>
               <p:ext uri="{D42A27DB-BD31-4B8C-83A1-F6EECF244321}">
-                <p14:modId xmlns:p14="http://schemas.microsoft.com/office/powerpoint/2010/main" val="1439025677"/>
+                <p14:modId xmlns:p14="http://schemas.microsoft.com/office/powerpoint/2010/main" val="777055671"/>
               </p:ext>
             </p:extLst>
           </p:nvPr>
         </p:nvGraphicFramePr>
         <p:xfrm>
-          <a:off x="838200" y="3184116"/>
+          <a:off x="838200" y="3429000"/>
           <a:ext cx="10515600" cy="2700000"/>
         </p:xfrm>
         <a:graphic>
@@ -38677,15 +38796,7 @@
                       </a:r>
                       <a:r>
                         <a:rPr sz="1800" baseline="30000" dirty="0"/>
-                        <a:t>13</a:t>
-                      </a:r>
-                      <a:r>
-                        <a:rPr sz="1800" dirty="0"/>
-                        <a:t>·</a:t>
-                      </a:r>
-                      <a:r>
-                        <a:rPr sz="1800" baseline="30000" dirty="0"/>
-                        <a:t>8</a:t>
+                        <a:t>13.8</a:t>
                       </a:r>
                       <a:r>
                         <a:rPr sz="1800" dirty="0"/>
@@ -38970,7 +39081,7 @@
         </p:nvSpPr>
         <p:spPr>
           <a:xfrm>
-            <a:off x="838200" y="4354998"/>
+            <a:off x="838200" y="4288323"/>
             <a:ext cx="10515600" cy="946089"/>
           </a:xfrm>
         </p:spPr>
@@ -41474,8 +41585,8 @@
           </a:p>
         </p:txBody>
       </p:sp>
-      <mc:AlternateContent xmlns:mc="http://schemas.openxmlformats.org/markup-compatibility/2006">
-        <mc:Choice xmlns:a14="http://schemas.microsoft.com/office/drawing/2010/main" Requires="a14">
+      <mc:AlternateContent xmlns:mc="http://schemas.openxmlformats.org/markup-compatibility/2006" xmlns:a14="http://schemas.microsoft.com/office/drawing/2010/main">
+        <mc:Choice Requires="a14">
           <p:sp>
             <p:nvSpPr>
               <p:cNvPr id="3" name="Content Placeholder 2"/>
@@ -41505,7 +41616,7 @@
                     <m:sSup>
                       <m:sSupPr>
                         <m:ctrlPr>
-                          <a:rPr lang="en-US">
+                          <a:rPr lang="en-US" i="1">
                             <a:latin typeface="Cambria Math" panose="02040503050406030204" pitchFamily="18" charset="0"/>
                           </a:rPr>
                         </m:ctrlPr>
@@ -41550,7 +41661,7 @@
                     <m:sSup>
                       <m:sSupPr>
                         <m:ctrlPr>
-                          <a:rPr lang="en-US">
+                          <a:rPr lang="en-US" i="1">
                             <a:latin typeface="Cambria Math" panose="02040503050406030204" pitchFamily="18" charset="0"/>
                           </a:rPr>
                         </m:ctrlPr>
@@ -41802,7 +41913,7 @@
                     <m:sSub>
                       <m:sSubPr>
                         <m:ctrlPr>
-                          <a:rPr lang="en-US">
+                          <a:rPr lang="en-US" i="1">
                             <a:latin typeface="Cambria Math" panose="02040503050406030204" pitchFamily="18" charset="0"/>
                           </a:rPr>
                         </m:ctrlPr>
@@ -41834,7 +41945,7 @@
             </p:txBody>
           </p:sp>
         </mc:Choice>
-        <mc:Fallback>
+        <mc:Fallback xmlns="">
           <p:sp>
             <p:nvSpPr>
               <p:cNvPr id="3" name="Content Placeholder 2"/>
@@ -42660,8 +42771,8 @@
           </a:p>
         </p:txBody>
       </p:sp>
-      <mc:AlternateContent xmlns:mc="http://schemas.openxmlformats.org/markup-compatibility/2006">
-        <mc:Choice xmlns:a14="http://schemas.microsoft.com/office/drawing/2010/main" Requires="a14">
+      <mc:AlternateContent xmlns:mc="http://schemas.openxmlformats.org/markup-compatibility/2006" xmlns:a14="http://schemas.microsoft.com/office/drawing/2010/main">
+        <mc:Choice Requires="a14">
           <p:sp>
             <p:nvSpPr>
               <p:cNvPr id="3" name="Content Placeholder 2"/>
@@ -42948,7 +43059,7 @@
                     <m:sSup>
                       <m:sSupPr>
                         <m:ctrlPr>
-                          <a:rPr lang="en-US">
+                          <a:rPr lang="en-US" i="1">
                             <a:latin typeface="Cambria Math" panose="02040503050406030204" pitchFamily="18" charset="0"/>
                           </a:rPr>
                         </m:ctrlPr>
@@ -42987,7 +43098,7 @@
                     <m:sSup>
                       <m:sSupPr>
                         <m:ctrlPr>
-                          <a:rPr lang="en-US">
+                          <a:rPr lang="en-US" i="1">
                             <a:latin typeface="Cambria Math" panose="02040503050406030204" pitchFamily="18" charset="0"/>
                           </a:rPr>
                         </m:ctrlPr>
@@ -43394,7 +43505,7 @@
             </p:txBody>
           </p:sp>
         </mc:Choice>
-        <mc:Fallback>
+        <mc:Fallback xmlns="">
           <p:sp>
             <p:nvSpPr>
               <p:cNvPr id="3" name="Content Placeholder 2"/>

</xml_diff>